<commit_message>
deck v7: visual pass — real paper figures + quality diagrams
Per feedback (slides too textual, diagrams below par): 10 of 13 slides now
carry a visual. Real figures extracted from the papers with credit lines:
AerialWaste positive examples (Torres 2023, CC BY) on Context; the Alari
2024 class-sample strip on Materials; a WorldView-3 building-level asbestos
classification example (Bonifazi 2026, CC BY) on material-level related
work. Alari thesis PDF fetched from politesi into the library. New quality
diagrams: task input->model->multi-label output (with a real Alari tile),
literature-search funnel with counts, per-sensor band chart (honest
NIR1/NIR2 overlap), proposal pipeline, evaluation grid schema. All
diagrams QA'd for overflow/clipping and rebuilt where needed.
</commit_message>
<xml_diff>
--- a/assets/deck_v7/deck_v7.pptx
+++ b/assets/deck_v7/deck_v7.pptx
@@ -3124,7 +3124,7 @@
           <a:p>
             <a:pPr algn="l">
               <a:lnSpc>
-                <a:spcPct val="115000"/>
+                <a:spcPct val="112000"/>
               </a:lnSpc>
               <a:spcAft>
                 <a:spcPts val="600"/>
@@ -3166,7 +3166,7 @@
           <a:p>
             <a:pPr algn="l">
               <a:lnSpc>
-                <a:spcPct val="115000"/>
+                <a:spcPct val="112000"/>
               </a:lnSpc>
               <a:spcAft>
                 <a:spcPts val="600"/>
@@ -3208,7 +3208,7 @@
           <a:p>
             <a:pPr algn="l">
               <a:lnSpc>
-                <a:spcPct val="115000"/>
+                <a:spcPct val="112000"/>
               </a:lnSpc>
               <a:spcAft>
                 <a:spcPts val="600"/>
@@ -3252,8 +3252,8 @@
         </p:nvSpPr>
         <p:spPr>
           <a:xfrm>
-            <a:off x="411480" y="274320"/>
-            <a:ext cx="8321040" cy="594360"/>
+            <a:off x="411480" y="256032"/>
+            <a:ext cx="8321040" cy="548640"/>
           </a:xfrm>
           <a:prstGeom prst="rect">
             <a:avLst/>
@@ -3268,7 +3268,7 @@
           <a:p>
             <a:pPr algn="l">
               <a:lnSpc>
-                <a:spcPct val="115000"/>
+                <a:spcPct val="112000"/>
               </a:lnSpc>
               <a:spcAft>
                 <a:spcPts val="600"/>
@@ -3310,7 +3310,7 @@
           <a:p>
             <a:pPr algn="l">
               <a:lnSpc>
-                <a:spcPct val="115000"/>
+                <a:spcPct val="112000"/>
               </a:lnSpc>
               <a:spcAft>
                 <a:spcPts val="600"/>
@@ -3329,7 +3329,7 @@
           <a:p>
             <a:pPr algn="l">
               <a:lnSpc>
-                <a:spcPct val="115000"/>
+                <a:spcPct val="112000"/>
               </a:lnSpc>
               <a:spcAft>
                 <a:spcPts val="600"/>
@@ -3348,7 +3348,7 @@
           <a:p>
             <a:pPr algn="l">
               <a:lnSpc>
-                <a:spcPct val="115000"/>
+                <a:spcPct val="112000"/>
               </a:lnSpc>
               <a:spcAft>
                 <a:spcPts val="600"/>
@@ -3367,7 +3367,7 @@
           <a:p>
             <a:pPr algn="l">
               <a:lnSpc>
-                <a:spcPct val="115000"/>
+                <a:spcPct val="112000"/>
               </a:lnSpc>
               <a:spcAft>
                 <a:spcPts val="600"/>
@@ -3386,7 +3386,7 @@
           <a:p>
             <a:pPr algn="l">
               <a:lnSpc>
-                <a:spcPct val="115000"/>
+                <a:spcPct val="112000"/>
               </a:lnSpc>
               <a:spcAft>
                 <a:spcPts val="600"/>
@@ -3412,7 +3412,7 @@
         </p:nvSpPr>
         <p:spPr>
           <a:xfrm>
-            <a:off x="411480" y="4791456"/>
+            <a:off x="411480" y="4809744"/>
             <a:ext cx="8321040" cy="237744"/>
           </a:xfrm>
           <a:prstGeom prst="rect">
@@ -3428,7 +3428,7 @@
           <a:p>
             <a:pPr algn="l">
               <a:lnSpc>
-                <a:spcPct val="115000"/>
+                <a:spcPct val="112000"/>
               </a:lnSpc>
               <a:spcAft>
                 <a:spcPts val="0"/>
@@ -3454,7 +3454,7 @@
         </p:nvSpPr>
         <p:spPr>
           <a:xfrm>
-            <a:off x="91440" y="4791456"/>
+            <a:off x="91440" y="4809744"/>
             <a:ext cx="411480" cy="256032"/>
           </a:xfrm>
           <a:prstGeom prst="rect">
@@ -3507,8 +3507,8 @@
         </p:nvSpPr>
         <p:spPr>
           <a:xfrm>
-            <a:off x="411480" y="274320"/>
-            <a:ext cx="8321040" cy="594360"/>
+            <a:off x="411480" y="256032"/>
+            <a:ext cx="8321040" cy="548640"/>
           </a:xfrm>
           <a:prstGeom prst="rect">
             <a:avLst/>
@@ -3523,7 +3523,7 @@
           <a:p>
             <a:pPr algn="l">
               <a:lnSpc>
-                <a:spcPct val="115000"/>
+                <a:spcPct val="112000"/>
               </a:lnSpc>
               <a:spcAft>
                 <a:spcPts val="600"/>
@@ -3549,8 +3549,8 @@
         </p:nvSpPr>
         <p:spPr>
           <a:xfrm>
-            <a:off x="411480" y="1097280"/>
-            <a:ext cx="8321040" cy="3520440"/>
+            <a:off x="411480" y="868680"/>
+            <a:ext cx="8321040" cy="1234440"/>
           </a:xfrm>
           <a:prstGeom prst="rect">
             <a:avLst/>
@@ -3558,116 +3558,83 @@
           <a:noFill/>
         </p:spPr>
         <p:txBody>
-          <a:bodyPr wrap="square" anchor="ctr">
+          <a:bodyPr wrap="square">
             <a:spAutoFit/>
           </a:bodyPr>
           <a:lstStyle/>
           <a:p>
             <a:pPr algn="l">
               <a:lnSpc>
-                <a:spcPct val="115000"/>
+                <a:spcPct val="112000"/>
               </a:lnSpc>
               <a:spcAft>
                 <a:spcPts val="600"/>
               </a:spcAft>
             </a:pPr>
             <a:r>
-              <a:rPr sz="1400" b="1" i="0">
+              <a:rPr sz="1200" b="1" i="0">
                 <a:solidFill>
                   <a:srgbClr val="1A1A1A"/>
                 </a:solidFill>
                 <a:latin typeface="Calibri"/>
               </a:rPr>
-              <a:t>Technique: multi-label image classification, continuing the group line (Gibellini 2025, Alari 2024).</a:t>
+              <a:t>Multi-label image classification, continuing the group line (Gibellini 2025, Alari 2024). Same taxonomy, input extended from RGB to VNIR.</a:t>
             </a:r>
           </a:p>
           <a:p>
             <a:pPr algn="l">
               <a:lnSpc>
-                <a:spcPct val="115000"/>
+                <a:spcPct val="112000"/>
               </a:lnSpc>
               <a:spcAft>
                 <a:spcPts val="600"/>
               </a:spcAft>
             </a:pPr>
             <a:r>
-              <a:rPr sz="1400" b="0" i="0">
+              <a:rPr sz="1200" b="0" i="0">
                 <a:solidFill>
                   <a:srgbClr val="1A1A1A"/>
                 </a:solidFill>
                 <a:latin typeface="Calibri"/>
               </a:rPr>
-              <a:t>Backbone: Swin-T with remote-sensing pretraining, the current group baseline. Extra VNIR bands enter by extending the input layer of the pretrained network.</a:t>
-            </a:r>
-          </a:p>
-          <a:p>
-            <a:pPr algn="l">
-              <a:lnSpc>
-                <a:spcPct val="115000"/>
-              </a:lnSpc>
-              <a:spcAft>
-                <a:spcPts val="600"/>
-              </a:spcAft>
-            </a:pPr>
-            <a:r>
-              <a:rPr sz="1400" b="0" i="0">
-                <a:solidFill>
-                  <a:srgbClr val="1A1A1A"/>
-                </a:solidFill>
-                <a:latin typeface="Calibri"/>
-              </a:rPr>
-              <a:t>Data: AerialWaste with the Alari material annotations as RGB baseline; WorldView-3 / Pléiades Neo acquisitions for the multispectral arm; Lombardy WFS asbestos registry (10,903 roofs) as ground truth for a controlled pilot.</a:t>
-            </a:r>
-          </a:p>
-          <a:p>
-            <a:pPr algn="l">
-              <a:lnSpc>
-                <a:spcPct val="115000"/>
-              </a:lnSpc>
-              <a:spcAft>
-                <a:spcPts val="600"/>
-              </a:spcAft>
-            </a:pPr>
-            <a:r>
-              <a:rPr sz="1400" b="0" i="0">
-                <a:solidFill>
-                  <a:srgbClr val="1A1A1A"/>
-                </a:solidFill>
-                <a:latin typeface="Calibri"/>
-              </a:rPr>
-              <a:t>Band ablation: RGB, then RGB + NIR, then full VNIR. Same architecture, same splits, only the input changes.</a:t>
-            </a:r>
-          </a:p>
-          <a:p>
-            <a:pPr algn="l">
-              <a:lnSpc>
-                <a:spcPct val="115000"/>
-              </a:lnSpc>
-              <a:spcAft>
-                <a:spcPts val="600"/>
-              </a:spcAft>
-            </a:pPr>
-            <a:r>
-              <a:rPr sz="1400" b="0" i="0">
-                <a:solidFill>
-                  <a:srgbClr val="1A1A1A"/>
-                </a:solidFill>
-                <a:latin typeface="Calibri"/>
-              </a:rPr>
-              <a:t>Asbestos pilot first: public labels, single material, clear VNIR evidence in literature. It validates the pipeline before the full taxonomy.</a:t>
-            </a:r>
-          </a:p>
-        </p:txBody>
-      </p:sp>
-      <p:sp>
-        <p:nvSpPr>
-          <p:cNvPr id="4" name="TextBox 3"/>
+              <a:t>Band ablation with everything else fixed: same architecture, same splits, only the input changes. Asbestos pilot first: public labels, one material, clear VNIR evidence.</a:t>
+            </a:r>
+          </a:p>
+        </p:txBody>
+      </p:sp>
+      <p:pic>
+        <p:nvPicPr>
+          <p:cNvPr id="4" name="Picture 3" descr="pipeline.png"/>
+          <p:cNvPicPr>
+            <a:picLocks noChangeAspect="1"/>
+          </p:cNvPicPr>
+          <p:nvPr/>
+        </p:nvPicPr>
+        <p:blipFill>
+          <a:blip r:embed="rId2"/>
+          <a:stretch>
+            <a:fillRect/>
+          </a:stretch>
+        </p:blipFill>
+        <p:spPr>
+          <a:xfrm>
+            <a:off x="1257467" y="2148840"/>
+            <a:ext cx="6629066" cy="2377440"/>
+          </a:xfrm>
+          <a:prstGeom prst="rect">
+            <a:avLst/>
+          </a:prstGeom>
+        </p:spPr>
+      </p:pic>
+      <p:sp>
+        <p:nvSpPr>
+          <p:cNvPr id="5" name="TextBox 4"/>
           <p:cNvSpPr txBox="1"/>
           <p:nvPr/>
         </p:nvSpPr>
         <p:spPr>
           <a:xfrm>
-            <a:off x="411480" y="4791456"/>
+            <a:off x="411480" y="4809744"/>
             <a:ext cx="8321040" cy="237744"/>
           </a:xfrm>
           <a:prstGeom prst="rect">
@@ -3683,7 +3650,7 @@
           <a:p>
             <a:pPr algn="l">
               <a:lnSpc>
-                <a:spcPct val="115000"/>
+                <a:spcPct val="112000"/>
               </a:lnSpc>
               <a:spcAft>
                 <a:spcPts val="0"/>
@@ -3696,20 +3663,20 @@
                 </a:solidFill>
                 <a:latin typeface="Calibri"/>
               </a:rPr>
-              <a:t>Continuity: same task and taxonomy as Alari 2024, extended from RGB to VNIR input.</a:t>
-            </a:r>
-          </a:p>
-        </p:txBody>
-      </p:sp>
-      <p:sp>
-        <p:nvSpPr>
-          <p:cNvPr id="5" name="TextBox 4"/>
+              <a:t>Backbone: Swin-T with remote-sensing pretraining (group baseline); extra bands enter via the input layer.</a:t>
+            </a:r>
+          </a:p>
+        </p:txBody>
+      </p:sp>
+      <p:sp>
+        <p:nvSpPr>
+          <p:cNvPr id="6" name="TextBox 5"/>
           <p:cNvSpPr txBox="1"/>
           <p:nvPr/>
         </p:nvSpPr>
         <p:spPr>
           <a:xfrm>
-            <a:off x="91440" y="4791456"/>
+            <a:off x="91440" y="4809744"/>
             <a:ext cx="411480" cy="256032"/>
           </a:xfrm>
           <a:prstGeom prst="rect">
@@ -3762,8 +3729,8 @@
         </p:nvSpPr>
         <p:spPr>
           <a:xfrm>
-            <a:off x="411480" y="274320"/>
-            <a:ext cx="8321040" cy="594360"/>
+            <a:off x="411480" y="256032"/>
+            <a:ext cx="8321040" cy="548640"/>
           </a:xfrm>
           <a:prstGeom prst="rect">
             <a:avLst/>
@@ -3778,7 +3745,7 @@
           <a:p>
             <a:pPr algn="l">
               <a:lnSpc>
-                <a:spcPct val="115000"/>
+                <a:spcPct val="112000"/>
               </a:lnSpc>
               <a:spcAft>
                 <a:spcPts val="600"/>
@@ -3804,8 +3771,8 @@
         </p:nvSpPr>
         <p:spPr>
           <a:xfrm>
-            <a:off x="411480" y="1097280"/>
-            <a:ext cx="8321040" cy="3520440"/>
+            <a:off x="411480" y="1051560"/>
+            <a:ext cx="4297680" cy="3566160"/>
           </a:xfrm>
           <a:prstGeom prst="rect">
             <a:avLst/>
@@ -3820,33 +3787,33 @@
           <a:p>
             <a:pPr algn="l">
               <a:lnSpc>
-                <a:spcPct val="115000"/>
+                <a:spcPct val="112000"/>
               </a:lnSpc>
               <a:spcAft>
                 <a:spcPts val="600"/>
               </a:spcAft>
             </a:pPr>
             <a:r>
-              <a:rPr sz="1400" b="0" i="0">
+              <a:rPr sz="1200" b="0" i="0">
                 <a:solidFill>
                   <a:srgbClr val="1A1A1A"/>
                 </a:solidFill>
                 <a:latin typeface="Calibri"/>
               </a:rPr>
-              <a:t>Per-material F1 alongside weighted and macro averages. Aggregates hide exactly the classes this thesis targets.</a:t>
+              <a:t>Per-material F1 alongside weighted and macro averages: aggregates hide exactly the classes this thesis targets.</a:t>
             </a:r>
           </a:p>
           <a:p>
             <a:pPr algn="l">
               <a:lnSpc>
-                <a:spcPct val="115000"/>
+                <a:spcPct val="112000"/>
               </a:lnSpc>
               <a:spcAft>
                 <a:spcPts val="600"/>
               </a:spcAft>
             </a:pPr>
             <a:r>
-              <a:rPr sz="1400" b="0" i="0">
+              <a:rPr sz="1200" b="0" i="0">
                 <a:solidFill>
                   <a:srgbClr val="1A1A1A"/>
                 </a:solidFill>
@@ -3858,71 +3825,95 @@
           <a:p>
             <a:pPr algn="l">
               <a:lnSpc>
-                <a:spcPct val="115000"/>
+                <a:spcPct val="112000"/>
               </a:lnSpc>
               <a:spcAft>
                 <a:spcPts val="600"/>
               </a:spcAft>
             </a:pPr>
             <a:r>
-              <a:rPr sz="1400" b="0" i="0">
+              <a:rPr sz="1200" b="0" i="0">
                 <a:solidFill>
                   <a:srgbClr val="1A1A1A"/>
                 </a:solidFill>
                 <a:latin typeface="Calibri"/>
               </a:rPr>
-              <a:t>Generalisation protocol: train and test on disjoint geographic areas, in addition to the standard split.</a:t>
+              <a:t>Generalisation: train and test on disjoint geographic areas, besides the standard split.</a:t>
             </a:r>
           </a:p>
           <a:p>
             <a:pPr algn="l">
               <a:lnSpc>
-                <a:spcPct val="115000"/>
+                <a:spcPct val="112000"/>
               </a:lnSpc>
               <a:spcAft>
                 <a:spcPts val="600"/>
               </a:spcAft>
             </a:pPr>
             <a:r>
-              <a:rPr sz="1400" b="0" i="0">
+              <a:rPr sz="1200" b="0" i="0">
                 <a:solidFill>
                   <a:srgbClr val="1A1A1A"/>
                 </a:solidFill>
                 <a:latin typeface="Calibri"/>
               </a:rPr>
-              <a:t>Reference points: wF1 69.2 / 59.4 (Alari 2024) for the multi-label task; Macro-F1 97.6 (Saba 2026, per-pixel) as upper reference for the asbestos pilot, not directly comparable.</a:t>
+              <a:t>Reference points: wF1 69.2 / 59.4 (Alari 2024); Macro-F1 97.6 (Saba 2026, per-pixel) as upper reference for the pilot, not directly comparable.</a:t>
             </a:r>
           </a:p>
           <a:p>
             <a:pPr algn="l">
               <a:lnSpc>
-                <a:spcPct val="115000"/>
+                <a:spcPct val="112000"/>
               </a:lnSpc>
               <a:spcAft>
                 <a:spcPts val="600"/>
               </a:spcAft>
             </a:pPr>
             <a:r>
-              <a:rPr sz="1400" b="0" i="0">
+              <a:rPr sz="1200" b="0" i="0">
                 <a:solidFill>
                   <a:srgbClr val="1A1A1A"/>
                 </a:solidFill>
                 <a:latin typeface="Calibri"/>
               </a:rPr>
-              <a:t>Outcome either way: if VNIR does not help a material, that is a documented negative result with practical value for sensor choice.</a:t>
-            </a:r>
-          </a:p>
-        </p:txBody>
-      </p:sp>
-      <p:sp>
-        <p:nvSpPr>
-          <p:cNvPr id="4" name="TextBox 3"/>
+              <a:t>If VNIR does not help a material, that is a documented negative result with practical value for sensor choice.</a:t>
+            </a:r>
+          </a:p>
+        </p:txBody>
+      </p:sp>
+      <p:pic>
+        <p:nvPicPr>
+          <p:cNvPr id="4" name="Picture 3" descr="eval_grid.png"/>
+          <p:cNvPicPr>
+            <a:picLocks noChangeAspect="1"/>
+          </p:cNvPicPr>
+          <p:nvPr/>
+        </p:nvPicPr>
+        <p:blipFill>
+          <a:blip r:embed="rId2"/>
+          <a:stretch>
+            <a:fillRect/>
+          </a:stretch>
+        </p:blipFill>
+        <p:spPr>
+          <a:xfrm>
+            <a:off x="4892040" y="1833755"/>
+            <a:ext cx="3886200" cy="1818890"/>
+          </a:xfrm>
+          <a:prstGeom prst="rect">
+            <a:avLst/>
+          </a:prstGeom>
+        </p:spPr>
+      </p:pic>
+      <p:sp>
+        <p:nvSpPr>
+          <p:cNvPr id="5" name="TextBox 4"/>
           <p:cNvSpPr txBox="1"/>
           <p:nvPr/>
         </p:nvSpPr>
         <p:spPr>
           <a:xfrm>
-            <a:off x="411480" y="4791456"/>
+            <a:off x="411480" y="4809744"/>
             <a:ext cx="8321040" cy="237744"/>
           </a:xfrm>
           <a:prstGeom prst="rect">
@@ -3938,7 +3929,7 @@
           <a:p>
             <a:pPr algn="l">
               <a:lnSpc>
-                <a:spcPct val="115000"/>
+                <a:spcPct val="112000"/>
               </a:lnSpc>
               <a:spcAft>
                 <a:spcPts val="0"/>
@@ -3958,13 +3949,13 @@
       </p:sp>
       <p:sp>
         <p:nvSpPr>
-          <p:cNvPr id="5" name="TextBox 4"/>
+          <p:cNvPr id="6" name="TextBox 5"/>
           <p:cNvSpPr txBox="1"/>
           <p:nvPr/>
         </p:nvSpPr>
         <p:spPr>
           <a:xfrm>
-            <a:off x="91440" y="4791456"/>
+            <a:off x="91440" y="4809744"/>
             <a:ext cx="411480" cy="256032"/>
           </a:xfrm>
           <a:prstGeom prst="rect">
@@ -4017,8 +4008,8 @@
         </p:nvSpPr>
         <p:spPr>
           <a:xfrm>
-            <a:off x="411480" y="274320"/>
-            <a:ext cx="8321040" cy="594360"/>
+            <a:off x="411480" y="256032"/>
+            <a:ext cx="8321040" cy="548640"/>
           </a:xfrm>
           <a:prstGeom prst="rect">
             <a:avLst/>
@@ -4033,7 +4024,7 @@
           <a:p>
             <a:pPr algn="l">
               <a:lnSpc>
-                <a:spcPct val="115000"/>
+                <a:spcPct val="112000"/>
               </a:lnSpc>
               <a:spcAft>
                 <a:spcPts val="600"/>
@@ -4075,7 +4066,7 @@
           <a:p>
             <a:pPr algn="l">
               <a:lnSpc>
-                <a:spcPct val="115000"/>
+                <a:spcPct val="112000"/>
               </a:lnSpc>
               <a:spcAft>
                 <a:spcPts val="600"/>
@@ -4094,7 +4085,7 @@
           <a:p>
             <a:pPr algn="l">
               <a:lnSpc>
-                <a:spcPct val="115000"/>
+                <a:spcPct val="112000"/>
               </a:lnSpc>
               <a:spcAft>
                 <a:spcPts val="600"/>
@@ -4113,7 +4104,7 @@
           <a:p>
             <a:pPr algn="l">
               <a:lnSpc>
-                <a:spcPct val="115000"/>
+                <a:spcPct val="112000"/>
               </a:lnSpc>
               <a:spcAft>
                 <a:spcPts val="600"/>
@@ -4132,7 +4123,7 @@
           <a:p>
             <a:pPr algn="l">
               <a:lnSpc>
-                <a:spcPct val="115000"/>
+                <a:spcPct val="112000"/>
               </a:lnSpc>
               <a:spcAft>
                 <a:spcPts val="600"/>
@@ -4151,7 +4142,7 @@
           <a:p>
             <a:pPr algn="l">
               <a:lnSpc>
-                <a:spcPct val="115000"/>
+                <a:spcPct val="112000"/>
               </a:lnSpc>
               <a:spcAft>
                 <a:spcPts val="600"/>
@@ -4170,7 +4161,7 @@
           <a:p>
             <a:pPr algn="l">
               <a:lnSpc>
-                <a:spcPct val="115000"/>
+                <a:spcPct val="112000"/>
               </a:lnSpc>
               <a:spcAft>
                 <a:spcPts val="600"/>
@@ -4189,7 +4180,7 @@
           <a:p>
             <a:pPr algn="l">
               <a:lnSpc>
-                <a:spcPct val="115000"/>
+                <a:spcPct val="112000"/>
               </a:lnSpc>
               <a:spcAft>
                 <a:spcPts val="600"/>
@@ -4215,7 +4206,7 @@
         </p:nvSpPr>
         <p:spPr>
           <a:xfrm>
-            <a:off x="411480" y="4791456"/>
+            <a:off x="411480" y="4809744"/>
             <a:ext cx="8321040" cy="237744"/>
           </a:xfrm>
           <a:prstGeom prst="rect">
@@ -4231,7 +4222,7 @@
           <a:p>
             <a:pPr algn="l">
               <a:lnSpc>
-                <a:spcPct val="115000"/>
+                <a:spcPct val="112000"/>
               </a:lnSpc>
               <a:spcAft>
                 <a:spcPts val="0"/>
@@ -4257,7 +4248,7 @@
         </p:nvSpPr>
         <p:spPr>
           <a:xfrm>
-            <a:off x="91440" y="4791456"/>
+            <a:off x="91440" y="4809744"/>
             <a:ext cx="411480" cy="256032"/>
           </a:xfrm>
           <a:prstGeom prst="rect">
@@ -4310,8 +4301,8 @@
         </p:nvSpPr>
         <p:spPr>
           <a:xfrm>
-            <a:off x="411480" y="274320"/>
-            <a:ext cx="8321040" cy="594360"/>
+            <a:off x="411480" y="256032"/>
+            <a:ext cx="8321040" cy="548640"/>
           </a:xfrm>
           <a:prstGeom prst="rect">
             <a:avLst/>
@@ -4326,7 +4317,7 @@
           <a:p>
             <a:pPr algn="l">
               <a:lnSpc>
-                <a:spcPct val="115000"/>
+                <a:spcPct val="112000"/>
               </a:lnSpc>
               <a:spcAft>
                 <a:spcPts val="600"/>
@@ -4352,8 +4343,8 @@
         </p:nvSpPr>
         <p:spPr>
           <a:xfrm>
-            <a:off x="411480" y="1097280"/>
-            <a:ext cx="8321040" cy="3520440"/>
+            <a:off x="411480" y="914400"/>
+            <a:ext cx="8321040" cy="1691640"/>
           </a:xfrm>
           <a:prstGeom prst="rect">
             <a:avLst/>
@@ -4361,97 +4352,102 @@
           <a:noFill/>
         </p:spPr>
         <p:txBody>
-          <a:bodyPr wrap="square" anchor="ctr">
+          <a:bodyPr wrap="square">
             <a:spAutoFit/>
           </a:bodyPr>
           <a:lstStyle/>
           <a:p>
             <a:pPr algn="l">
               <a:lnSpc>
-                <a:spcPct val="115000"/>
+                <a:spcPct val="112000"/>
               </a:lnSpc>
               <a:spcAft>
                 <a:spcPts val="600"/>
               </a:spcAft>
             </a:pPr>
             <a:r>
-              <a:rPr sz="1400" b="0" i="0">
+              <a:rPr sz="1250" b="0" i="0">
                 <a:solidFill>
                   <a:srgbClr val="1A1A1A"/>
                 </a:solidFill>
                 <a:latin typeface="Calibri"/>
               </a:rPr>
-              <a:t>Illegal waste dumping is an environmental crime with direct public-health consequences.</a:t>
+              <a:t>Illegal waste dumping is an environmental crime with direct public-health consequences. Agencies (ARPA) have limited inspection capacity, and priority depends on what is dumped: rubble, plastics and asbestos-cement imply very different hazards.</a:t>
             </a:r>
           </a:p>
           <a:p>
             <a:pPr algn="l">
               <a:lnSpc>
-                <a:spcPct val="115000"/>
+                <a:spcPct val="112000"/>
               </a:lnSpc>
               <a:spcAft>
                 <a:spcPts val="600"/>
               </a:spcAft>
             </a:pPr>
             <a:r>
-              <a:rPr sz="1400" b="0" i="0">
+              <a:rPr sz="1250" b="0" i="0">
                 <a:solidFill>
                   <a:srgbClr val="1A1A1A"/>
                 </a:solidFill>
                 <a:latin typeface="Calibri"/>
               </a:rPr>
-              <a:t>Environmental agencies (ARPA) have limited inspection capacity. Intervention priority depends on what is dumped: inert rubble, plastics and asbestos-cement imply very different hazards.</a:t>
+              <a:t>Detecting dump sites from images is mature. Recognising the material is not: the reference survey (50 works, 1987-2023, almost all RGB) marks it as an open problem.</a:t>
             </a:r>
           </a:p>
           <a:p>
             <a:pPr algn="l">
               <a:lnSpc>
-                <a:spcPct val="115000"/>
+                <a:spcPct val="112000"/>
               </a:lnSpc>
               <a:spcAft>
                 <a:spcPts val="600"/>
               </a:spcAft>
             </a:pPr>
             <a:r>
-              <a:rPr sz="1400" b="0" i="0">
+              <a:rPr sz="1250" b="0" i="0">
                 <a:solidFill>
                   <a:srgbClr val="1A1A1A"/>
                 </a:solidFill>
                 <a:latin typeface="Calibri"/>
               </a:rPr>
-              <a:t>Automatic detection of dump sites from aerial and satellite images is mature. Recognising the material is not: the reference survey lists 50 works from 1987 to 2023, almost all RGB, and marks material identification as an open problem.</a:t>
-            </a:r>
-          </a:p>
-          <a:p>
-            <a:pPr algn="l">
-              <a:lnSpc>
-                <a:spcPct val="115000"/>
-              </a:lnSpc>
-              <a:spcAft>
-                <a:spcPts val="600"/>
-              </a:spcAft>
-            </a:pPr>
-            <a:r>
-              <a:rPr sz="1400" b="0" i="0">
-                <a:solidFill>
-                  <a:srgbClr val="1A1A1A"/>
-                </a:solidFill>
-                <a:latin typeface="Calibri"/>
-              </a:rPr>
-              <a:t>Within PERIVALLON, one thesis in the group has addressed material classification directly (Alari 2024). This work starts from there.</a:t>
-            </a:r>
-          </a:p>
-        </p:txBody>
-      </p:sp>
-      <p:sp>
-        <p:nvSpPr>
-          <p:cNvPr id="4" name="TextBox 3"/>
+              <a:t>One thesis in the group has addressed material classification directly (Alari 2024). This work starts from there.</a:t>
+            </a:r>
+          </a:p>
+        </p:txBody>
+      </p:sp>
+      <p:pic>
+        <p:nvPicPr>
+          <p:cNvPr id="4" name="Picture 3" descr="torres_examples.png"/>
+          <p:cNvPicPr>
+            <a:picLocks noChangeAspect="1"/>
+          </p:cNvPicPr>
+          <p:nvPr/>
+        </p:nvPicPr>
+        <p:blipFill>
+          <a:blip r:embed="rId2"/>
+          <a:stretch>
+            <a:fillRect/>
+          </a:stretch>
+        </p:blipFill>
+        <p:spPr>
+          <a:xfrm>
+            <a:off x="1075636" y="2697480"/>
+            <a:ext cx="6992728" cy="2011680"/>
+          </a:xfrm>
+          <a:prstGeom prst="rect">
+            <a:avLst/>
+          </a:prstGeom>
+        </p:spPr>
+      </p:pic>
+      <p:sp>
+        <p:nvSpPr>
+          <p:cNvPr id="5" name="TextBox 4"/>
           <p:cNvSpPr txBox="1"/>
           <p:nvPr/>
         </p:nvSpPr>
         <p:spPr>
           <a:xfrm>
-            <a:off x="411480" y="4791456"/>
+            <a:off x="411480" y="4809744"/>
             <a:ext cx="8321040" cy="237744"/>
           </a:xfrm>
           <a:prstGeom prst="rect">
@@ -4467,7 +4463,7 @@
           <a:p>
             <a:pPr algn="l">
               <a:lnSpc>
-                <a:spcPct val="115000"/>
+                <a:spcPct val="112000"/>
               </a:lnSpc>
               <a:spcAft>
                 <a:spcPts val="0"/>
@@ -4480,20 +4476,20 @@
                 </a:solidFill>
                 <a:latin typeface="Calibri"/>
               </a:rPr>
-              <a:t>Fraternali et al. 2024, survey (arXiv:2402.09066)  ·  Alari 2024, M.Sc. thesis PoliMi (10589/230633)</a:t>
-            </a:r>
-          </a:p>
-        </p:txBody>
-      </p:sp>
-      <p:sp>
-        <p:nvSpPr>
-          <p:cNvPr id="5" name="TextBox 4"/>
+              <a:t>Images: AerialWaste positive examples, Torres and Fraternali 2023 (CC BY 4.0)  ·  survey: Fraternali et al. 2024</a:t>
+            </a:r>
+          </a:p>
+        </p:txBody>
+      </p:sp>
+      <p:sp>
+        <p:nvSpPr>
+          <p:cNvPr id="6" name="TextBox 5"/>
           <p:cNvSpPr txBox="1"/>
           <p:nvPr/>
         </p:nvSpPr>
         <p:spPr>
           <a:xfrm>
-            <a:off x="91440" y="4791456"/>
+            <a:off x="91440" y="4809744"/>
             <a:ext cx="411480" cy="256032"/>
           </a:xfrm>
           <a:prstGeom prst="rect">
@@ -4546,8 +4542,8 @@
         </p:nvSpPr>
         <p:spPr>
           <a:xfrm>
-            <a:off x="411480" y="274320"/>
-            <a:ext cx="8321040" cy="594360"/>
+            <a:off x="411480" y="256032"/>
+            <a:ext cx="8321040" cy="548640"/>
           </a:xfrm>
           <a:prstGeom prst="rect">
             <a:avLst/>
@@ -4562,7 +4558,7 @@
           <a:p>
             <a:pPr algn="l">
               <a:lnSpc>
-                <a:spcPct val="115000"/>
+                <a:spcPct val="112000"/>
               </a:lnSpc>
               <a:spcAft>
                 <a:spcPts val="600"/>
@@ -4588,8 +4584,8 @@
         </p:nvSpPr>
         <p:spPr>
           <a:xfrm>
-            <a:off x="411480" y="1097280"/>
-            <a:ext cx="8321040" cy="3520440"/>
+            <a:off x="411480" y="868680"/>
+            <a:ext cx="8321040" cy="1965960"/>
           </a:xfrm>
           <a:prstGeom prst="rect">
             <a:avLst/>
@@ -4597,21 +4593,21 @@
           <a:noFill/>
         </p:spPr>
         <p:txBody>
-          <a:bodyPr wrap="square" anchor="ctr">
+          <a:bodyPr wrap="square">
             <a:spAutoFit/>
           </a:bodyPr>
           <a:lstStyle/>
           <a:p>
             <a:pPr algn="l">
               <a:lnSpc>
-                <a:spcPct val="115000"/>
+                <a:spcPct val="112000"/>
               </a:lnSpc>
               <a:spcAft>
                 <a:spcPts val="600"/>
               </a:spcAft>
             </a:pPr>
             <a:r>
-              <a:rPr sz="1400" b="1" i="0">
+              <a:rPr sz="1250" b="1" i="0">
                 <a:solidFill>
                   <a:srgbClr val="1A1A1A"/>
                 </a:solidFill>
@@ -4623,90 +4619,95 @@
           <a:p>
             <a:pPr algn="l">
               <a:lnSpc>
-                <a:spcPct val="115000"/>
+                <a:spcPct val="112000"/>
               </a:lnSpc>
               <a:spcAft>
                 <a:spcPts val="600"/>
               </a:spcAft>
             </a:pPr>
             <a:r>
-              <a:rPr sz="1400" b="0" i="0">
+              <a:rPr sz="1250" b="0" i="0">
                 <a:solidFill>
                   <a:srgbClr val="1A1A1A"/>
                 </a:solidFill>
                 <a:latin typeface="Calibri"/>
               </a:rPr>
-              <a:t>Input: very-high-resolution optical imagery, GSD 0.2 to 1.3 m: aerial RGB for the baseline (AerialWaste), satellite VNIR for the multispectral arm. Bands: RGB and VNIR (up to 8). SWIR is excluded: not part of the planned acquisitions, and its 3.7 m GSD does not match the sub-metre task. Sentinel-2 (10-20 m) is excluded: too coarse.</a:t>
+              <a:t>Input: VHR optical imagery, GSD 0.2 to 1.3 m (aerial RGB baseline; satellite VNIR arm, up to 8 bands). SWIR excluded: not in the planned acquisitions, and its 3.7 m GSD does not match the task. Sentinel-2 excluded: too coarse.</a:t>
             </a:r>
           </a:p>
           <a:p>
             <a:pPr algn="l">
               <a:lnSpc>
-                <a:spcPct val="115000"/>
+                <a:spcPct val="112000"/>
               </a:lnSpc>
               <a:spcAft>
                 <a:spcPts val="600"/>
               </a:spcAft>
             </a:pPr>
             <a:r>
-              <a:rPr sz="1400" b="0" i="0">
+              <a:rPr sz="1250" b="0" i="0">
                 <a:solidFill>
                   <a:srgbClr val="1A1A1A"/>
                 </a:solidFill>
                 <a:latin typeface="Calibri"/>
               </a:rPr>
-              <a:t>Output: the set of materials present in each image, from a fixed list of categories.</a:t>
+              <a:t>Technique: classification, not detection or segmentation. Annotations are image-level (Alari 2024: 11,477 multi-label); waste piles have no stable shape for boxes; no masks exist.</a:t>
             </a:r>
           </a:p>
           <a:p>
             <a:pPr algn="l">
               <a:lnSpc>
-                <a:spcPct val="115000"/>
+                <a:spcPct val="112000"/>
               </a:lnSpc>
               <a:spcAft>
                 <a:spcPts val="600"/>
               </a:spcAft>
             </a:pPr>
             <a:r>
-              <a:rPr sz="1400" b="0" i="0">
+              <a:rPr sz="1250" b="1" i="0">
                 <a:solidFill>
                   <a:srgbClr val="1A1A1A"/>
                 </a:solidFill>
                 <a:latin typeface="Calibri"/>
               </a:rPr>
-              <a:t>Technique: classification, not object detection or segmentation. The available annotations are image-level (Alari 2024: over 11,400 multi-label annotations). Waste piles have no stable shape for boxes, and no segmentation masks exist for these datasets.</a:t>
-            </a:r>
-          </a:p>
-          <a:p>
-            <a:pPr algn="l">
-              <a:lnSpc>
-                <a:spcPct val="115000"/>
-              </a:lnSpc>
-              <a:spcAft>
-                <a:spcPts val="600"/>
-              </a:spcAft>
-            </a:pPr>
-            <a:r>
-              <a:rPr sz="1400" b="1" i="0">
-                <a:solidFill>
-                  <a:srgbClr val="1A1A1A"/>
-                </a:solidFill>
-                <a:latin typeface="Calibri"/>
-              </a:rPr>
-              <a:t>Research question: does VNIR multispectral input improve waste-material classification compared with RGB, and for which materials?</a:t>
-            </a:r>
-          </a:p>
-        </p:txBody>
-      </p:sp>
-      <p:sp>
-        <p:nvSpPr>
-          <p:cNvPr id="4" name="TextBox 3"/>
+              <a:t>Research question: does VNIR input improve waste-material classification over RGB, and for which materials?</a:t>
+            </a:r>
+          </a:p>
+        </p:txBody>
+      </p:sp>
+      <p:pic>
+        <p:nvPicPr>
+          <p:cNvPr id="4" name="Picture 3" descr="task_io.png"/>
+          <p:cNvPicPr>
+            <a:picLocks noChangeAspect="1"/>
+          </p:cNvPicPr>
+          <p:nvPr/>
+        </p:nvPicPr>
+        <p:blipFill>
+          <a:blip r:embed="rId2"/>
+          <a:stretch>
+            <a:fillRect/>
+          </a:stretch>
+        </p:blipFill>
+        <p:spPr>
+          <a:xfrm>
+            <a:off x="1858309" y="2926080"/>
+            <a:ext cx="5427382" cy="1783080"/>
+          </a:xfrm>
+          <a:prstGeom prst="rect">
+            <a:avLst/>
+          </a:prstGeom>
+        </p:spPr>
+      </p:pic>
+      <p:sp>
+        <p:nvSpPr>
+          <p:cNvPr id="5" name="TextBox 4"/>
           <p:cNvSpPr txBox="1"/>
           <p:nvPr/>
         </p:nvSpPr>
         <p:spPr>
           <a:xfrm>
-            <a:off x="411480" y="4791456"/>
+            <a:off x="411480" y="4809744"/>
             <a:ext cx="8321040" cy="237744"/>
           </a:xfrm>
           <a:prstGeom prst="rect">
@@ -4722,7 +4723,7 @@
           <a:p>
             <a:pPr algn="l">
               <a:lnSpc>
-                <a:spcPct val="115000"/>
+                <a:spcPct val="112000"/>
               </a:lnSpc>
               <a:spcAft>
                 <a:spcPts val="0"/>
@@ -4735,20 +4736,20 @@
                 </a:solidFill>
                 <a:latin typeface="Calibri"/>
               </a:rPr>
-              <a:t>Annotations: Alari 2024  ·  imagery: WorldView-3, Pléiades Neo (VNIR + pan)</a:t>
-            </a:r>
-          </a:p>
-        </p:txBody>
-      </p:sp>
-      <p:sp>
-        <p:nvSpPr>
-          <p:cNvPr id="5" name="TextBox 4"/>
+              <a:t>Annotations: Alari 2024  ·  imagery: WorldView-3, Pléiades Neo (VNIR + pan)  ·  tile: Alari 2024</a:t>
+            </a:r>
+          </a:p>
+        </p:txBody>
+      </p:sp>
+      <p:sp>
+        <p:nvSpPr>
+          <p:cNvPr id="6" name="TextBox 5"/>
           <p:cNvSpPr txBox="1"/>
           <p:nvPr/>
         </p:nvSpPr>
         <p:spPr>
           <a:xfrm>
-            <a:off x="91440" y="4791456"/>
+            <a:off x="91440" y="4809744"/>
             <a:ext cx="411480" cy="256032"/>
           </a:xfrm>
           <a:prstGeom prst="rect">
@@ -4801,8 +4802,8 @@
         </p:nvSpPr>
         <p:spPr>
           <a:xfrm>
-            <a:off x="411480" y="274320"/>
-            <a:ext cx="8321040" cy="594360"/>
+            <a:off x="411480" y="256032"/>
+            <a:ext cx="8321040" cy="548640"/>
           </a:xfrm>
           <a:prstGeom prst="rect">
             <a:avLst/>
@@ -4817,7 +4818,7 @@
           <a:p>
             <a:pPr algn="l">
               <a:lnSpc>
-                <a:spcPct val="115000"/>
+                <a:spcPct val="112000"/>
               </a:lnSpc>
               <a:spcAft>
                 <a:spcPts val="600"/>
@@ -4835,17 +4836,41 @@
           </a:p>
         </p:txBody>
       </p:sp>
+      <p:pic>
+        <p:nvPicPr>
+          <p:cNvPr id="3" name="Picture 2" descr="alari_row1.png"/>
+          <p:cNvPicPr>
+            <a:picLocks noChangeAspect="1"/>
+          </p:cNvPicPr>
+          <p:nvPr/>
+        </p:nvPicPr>
+        <p:blipFill>
+          <a:blip r:embed="rId2"/>
+          <a:stretch>
+            <a:fillRect/>
+          </a:stretch>
+        </p:blipFill>
+        <p:spPr>
+          <a:xfrm>
+            <a:off x="1295141" y="868680"/>
+            <a:ext cx="6553717" cy="1517904"/>
+          </a:xfrm>
+          <a:prstGeom prst="rect">
+            <a:avLst/>
+          </a:prstGeom>
+        </p:spPr>
+      </p:pic>
       <p:graphicFrame>
         <p:nvGraphicFramePr>
-          <p:cNvPr id="3" name="Table 2"/>
+          <p:cNvPr id="4" name="Table 3"/>
           <p:cNvGraphicFramePr>
             <a:graphicFrameLocks noGrp="1"/>
           </p:cNvGraphicFramePr>
           <p:nvPr/>
         </p:nvGraphicFramePr>
         <p:xfrm>
-          <a:off x="411480" y="1147572"/>
-          <a:ext cx="8321040" cy="3419856"/>
+          <a:off x="411480" y="2487168"/>
+          <a:ext cx="8321040" cy="1938528"/>
         </p:xfrm>
         <a:graphic>
           <a:graphicData uri="http://schemas.openxmlformats.org/drawingml/2006/table">
@@ -4854,12 +4879,12 @@
                 <a:tableStyleId>{5C22544A-7EE6-4342-B048-85BDC9FD1C3A}</a:tableStyleId>
               </a:tblPr>
               <a:tblGrid>
-                <a:gridCol w="2286000"/>
-                <a:gridCol w="1554480"/>
-                <a:gridCol w="2286000"/>
-                <a:gridCol w="2194560"/>
+                <a:gridCol w="3108960"/>
+                <a:gridCol w="868680"/>
+                <a:gridCol w="1691640"/>
+                <a:gridCol w="2651760"/>
               </a:tblGrid>
-              <a:tr h="347472">
+              <a:tr h="329184">
                 <a:tc>
                   <a:txBody>
                     <a:bodyPr/>
@@ -4881,7 +4906,7 @@
                       </a:r>
                     </a:p>
                   </a:txBody>
-                  <a:tcPr anchor="ctr" marL="54864" marR="45720" marT="18288" marB="18288">
+                  <a:tcPr anchor="ctr" marL="45720" marR="36576" marT="18288" marB="18288">
                     <a:solidFill>
                       <a:srgbClr val="DDDDDD"/>
                     </a:solidFill>
@@ -4904,11 +4929,11 @@
                           </a:solidFill>
                           <a:latin typeface="Calibri"/>
                         </a:rPr>
-                        <a:t>Classification target</a:t>
+                        <a:t>Target</a:t>
                       </a:r>
                     </a:p>
                   </a:txBody>
-                  <a:tcPr anchor="ctr" marL="54864" marR="45720" marT="18288" marB="18288">
+                  <a:tcPr anchor="ctr" marL="45720" marR="36576" marT="18288" marB="18288">
                     <a:solidFill>
                       <a:srgbClr val="DDDDDD"/>
                     </a:solidFill>
@@ -4931,11 +4956,11 @@
                           </a:solidFill>
                           <a:latin typeface="Calibri"/>
                         </a:rPr>
-                        <a:t>Spectral analysis (RGB vs VNIR)</a:t>
+                        <a:t>Spectral analysis</a:t>
                       </a:r>
                     </a:p>
                   </a:txBody>
-                  <a:tcPr anchor="ctr" marL="54864" marR="45720" marT="18288" marB="18288">
+                  <a:tcPr anchor="ctr" marL="45720" marR="36576" marT="18288" marB="18288">
                     <a:solidFill>
                       <a:srgbClr val="DDDDDD"/>
                     </a:solidFill>
@@ -4958,18 +4983,18 @@
                           </a:solidFill>
                           <a:latin typeface="Calibri"/>
                         </a:rPr>
-                        <a:t>Note</a:t>
+                        <a:t>Reason</a:t>
                       </a:r>
                     </a:p>
                   </a:txBody>
-                  <a:tcPr anchor="ctr" marL="54864" marR="45720" marT="18288" marB="18288">
+                  <a:tcPr anchor="ctr" marL="45720" marR="36576" marT="18288" marB="18288">
                     <a:solidFill>
                       <a:srgbClr val="DDDDDD"/>
                     </a:solidFill>
                   </a:tcPr>
                 </a:tc>
               </a:tr>
-              <a:tr h="384048">
+              <a:tr h="402336">
                 <a:tc>
                   <a:txBody>
                     <a:bodyPr/>
@@ -4987,11 +5012,11 @@
                           </a:solidFill>
                           <a:latin typeface="Calibri"/>
                         </a:rPr>
-                        <a:t>Rubble / inert</a:t>
+                        <a:t>Rubble, plastic, wood, tires</a:t>
                       </a:r>
                     </a:p>
                   </a:txBody>
-                  <a:tcPr anchor="ctr" marL="54864" marR="45720" marT="18288" marB="18288">
+                  <a:tcPr anchor="ctr" marL="45720" marR="36576" marT="18288" marB="18288">
                     <a:solidFill>
                       <a:srgbClr val="FFFFFF"/>
                     </a:solidFill>
@@ -5018,7 +5043,7 @@
                       </a:r>
                     </a:p>
                   </a:txBody>
-                  <a:tcPr anchor="ctr" marL="54864" marR="45720" marT="18288" marB="18288">
+                  <a:tcPr anchor="ctr" marL="45720" marR="36576" marT="18288" marB="18288">
                     <a:solidFill>
                       <a:srgbClr val="FFFFFF"/>
                     </a:solidFill>
@@ -5045,7 +5070,7 @@
                       </a:r>
                     </a:p>
                   </a:txBody>
-                  <a:tcPr anchor="ctr" marL="54864" marR="45720" marT="18288" marB="18288">
+                  <a:tcPr anchor="ctr" marL="45720" marR="36576" marT="18288" marB="18288">
                     <a:solidFill>
                       <a:srgbClr val="FFFFFF"/>
                     </a:solidFill>
@@ -5068,18 +5093,18 @@
                           </a:solidFill>
                           <a:latin typeface="Calibri"/>
                         </a:rPr>
-                        <a:t>frequent; grey, confusable in RGB</a:t>
+                        <a:t>frequent and confusable in RGB</a:t>
                       </a:r>
                     </a:p>
                   </a:txBody>
-                  <a:tcPr anchor="ctr" marL="54864" marR="45720" marT="18288" marB="18288">
+                  <a:tcPr anchor="ctr" marL="45720" marR="36576" marT="18288" marB="18288">
                     <a:solidFill>
                       <a:srgbClr val="FFFFFF"/>
                     </a:solidFill>
                   </a:tcPr>
                 </a:tc>
               </a:tr>
-              <a:tr h="384048">
+              <a:tr h="402336">
                 <a:tc>
                   <a:txBody>
                     <a:bodyPr/>
@@ -5097,11 +5122,11 @@
                           </a:solidFill>
                           <a:latin typeface="Calibri"/>
                         </a:rPr>
-                        <a:t>Plastic</a:t>
+                        <a:t>Asbestos-cement</a:t>
                       </a:r>
                     </a:p>
                   </a:txBody>
-                  <a:tcPr anchor="ctr" marL="54864" marR="45720" marT="18288" marB="18288">
+                  <a:tcPr anchor="ctr" marL="45720" marR="36576" marT="18288" marB="18288">
                     <a:solidFill>
                       <a:srgbClr val="F5F5F5"/>
                     </a:solidFill>
@@ -5128,7 +5153,200 @@
                       </a:r>
                     </a:p>
                   </a:txBody>
-                  <a:tcPr anchor="ctr" marL="54864" marR="45720" marT="18288" marB="18288">
+                  <a:tcPr anchor="ctr" marL="45720" marR="36576" marT="18288" marB="18288">
+                    <a:solidFill>
+                      <a:srgbClr val="F5F5F5"/>
+                    </a:solidFill>
+                  </a:tcPr>
+                </a:tc>
+                <a:tc>
+                  <a:txBody>
+                    <a:bodyPr/>
+                    <a:lstStyle/>
+                    <a:p>
+                      <a:pPr>
+                        <a:lnSpc>
+                          <a:spcPct val="100000"/>
+                        </a:lnSpc>
+                      </a:pPr>
+                      <a:r>
+                        <a:rPr sz="900" b="0">
+                          <a:solidFill>
+                            <a:srgbClr val="1A1A1A"/>
+                          </a:solidFill>
+                          <a:latin typeface="Calibri"/>
+                        </a:rPr>
+                        <a:t>yes, dedicated pilot</a:t>
+                      </a:r>
+                    </a:p>
+                  </a:txBody>
+                  <a:tcPr anchor="ctr" marL="45720" marR="36576" marT="18288" marB="18288">
+                    <a:solidFill>
+                      <a:srgbClr val="F5F5F5"/>
+                    </a:solidFill>
+                  </a:tcPr>
+                </a:tc>
+                <a:tc>
+                  <a:txBody>
+                    <a:bodyPr/>
+                    <a:lstStyle/>
+                    <a:p>
+                      <a:pPr>
+                        <a:lnSpc>
+                          <a:spcPct val="100000"/>
+                        </a:lnSpc>
+                      </a:pPr>
+                      <a:r>
+                        <a:rPr sz="900" b="0">
+                          <a:solidFill>
+                            <a:srgbClr val="1A1A1A"/>
+                          </a:solidFill>
+                          <a:latin typeface="Calibri"/>
+                        </a:rPr>
+                        <a:t>public regional ground truth (WFS)</a:t>
+                      </a:r>
+                    </a:p>
+                  </a:txBody>
+                  <a:tcPr anchor="ctr" marL="45720" marR="36576" marT="18288" marB="18288">
+                    <a:solidFill>
+                      <a:srgbClr val="F5F5F5"/>
+                    </a:solidFill>
+                  </a:tcPr>
+                </a:tc>
+              </a:tr>
+              <a:tr h="402336">
+                <a:tc>
+                  <a:txBody>
+                    <a:bodyPr/>
+                    <a:lstStyle/>
+                    <a:p>
+                      <a:pPr>
+                        <a:lnSpc>
+                          <a:spcPct val="100000"/>
+                        </a:lnSpc>
+                      </a:pPr>
+                      <a:r>
+                        <a:rPr sz="900" b="0">
+                          <a:solidFill>
+                            <a:srgbClr val="1A1A1A"/>
+                          </a:solidFill>
+                          <a:latin typeface="Calibri"/>
+                        </a:rPr>
+                        <a:t>Vehicles, tanks, containers, scrap, bulky, big bags</a:t>
+                      </a:r>
+                    </a:p>
+                  </a:txBody>
+                  <a:tcPr anchor="ctr" marL="45720" marR="36576" marT="18288" marB="18288">
+                    <a:solidFill>
+                      <a:srgbClr val="FFFFFF"/>
+                    </a:solidFill>
+                  </a:tcPr>
+                </a:tc>
+                <a:tc>
+                  <a:txBody>
+                    <a:bodyPr/>
+                    <a:lstStyle/>
+                    <a:p>
+                      <a:pPr>
+                        <a:lnSpc>
+                          <a:spcPct val="100000"/>
+                        </a:lnSpc>
+                      </a:pPr>
+                      <a:r>
+                        <a:rPr sz="900" b="0">
+                          <a:solidFill>
+                            <a:srgbClr val="1A1A1A"/>
+                          </a:solidFill>
+                          <a:latin typeface="Calibri"/>
+                        </a:rPr>
+                        <a:t>yes</a:t>
+                      </a:r>
+                    </a:p>
+                  </a:txBody>
+                  <a:tcPr anchor="ctr" marL="45720" marR="36576" marT="18288" marB="18288">
+                    <a:solidFill>
+                      <a:srgbClr val="FFFFFF"/>
+                    </a:solidFill>
+                  </a:tcPr>
+                </a:tc>
+                <a:tc>
+                  <a:txBody>
+                    <a:bodyPr/>
+                    <a:lstStyle/>
+                    <a:p>
+                      <a:pPr>
+                        <a:lnSpc>
+                          <a:spcPct val="100000"/>
+                        </a:lnSpc>
+                      </a:pPr>
+                      <a:r>
+                        <a:rPr sz="900" b="0">
+                          <a:solidFill>
+                            <a:srgbClr val="1A1A1A"/>
+                          </a:solidFill>
+                          <a:latin typeface="Calibri"/>
+                        </a:rPr>
+                        <a:t>no</a:t>
+                      </a:r>
+                    </a:p>
+                  </a:txBody>
+                  <a:tcPr anchor="ctr" marL="45720" marR="36576" marT="18288" marB="18288">
+                    <a:solidFill>
+                      <a:srgbClr val="FFFFFF"/>
+                    </a:solidFill>
+                  </a:tcPr>
+                </a:tc>
+                <a:tc>
+                  <a:txBody>
+                    <a:bodyPr/>
+                    <a:lstStyle/>
+                    <a:p>
+                      <a:pPr>
+                        <a:lnSpc>
+                          <a:spcPct val="100000"/>
+                        </a:lnSpc>
+                      </a:pPr>
+                      <a:r>
+                        <a:rPr sz="900" b="0">
+                          <a:solidFill>
+                            <a:srgbClr val="1A1A1A"/>
+                          </a:solidFill>
+                          <a:latin typeface="Calibri"/>
+                        </a:rPr>
+                        <a:t>shape-based; RGB sufficient in literature</a:t>
+                      </a:r>
+                    </a:p>
+                  </a:txBody>
+                  <a:tcPr anchor="ctr" marL="45720" marR="36576" marT="18288" marB="18288">
+                    <a:solidFill>
+                      <a:srgbClr val="FFFFFF"/>
+                    </a:solidFill>
+                  </a:tcPr>
+                </a:tc>
+              </a:tr>
+              <a:tr h="402336">
+                <a:tc>
+                  <a:txBody>
+                    <a:bodyPr/>
+                    <a:lstStyle/>
+                    <a:p>
+                      <a:pPr>
+                        <a:lnSpc>
+                          <a:spcPct val="100000"/>
+                        </a:lnSpc>
+                      </a:pPr>
+                      <a:r>
+                        <a:rPr sz="900" b="0">
+                          <a:solidFill>
+                            <a:srgbClr val="1A1A1A"/>
+                          </a:solidFill>
+                          <a:latin typeface="Calibri"/>
+                        </a:rPr>
+                        <a:t>Sludge, foundry waste</a:t>
+                      </a:r>
+                    </a:p>
+                  </a:txBody>
+                  <a:tcPr anchor="ctr" marL="45720" marR="36576" marT="18288" marB="18288">
                     <a:solidFill>
                       <a:srgbClr val="F5F5F5"/>
                     </a:solidFill>
@@ -5155,420 +5373,7 @@
                       </a:r>
                     </a:p>
                   </a:txBody>
-                  <a:tcPr anchor="ctr" marL="54864" marR="45720" marT="18288" marB="18288">
-                    <a:solidFill>
-                      <a:srgbClr val="F5F5F5"/>
-                    </a:solidFill>
-                  </a:tcPr>
-                </a:tc>
-                <a:tc>
-                  <a:txBody>
-                    <a:bodyPr/>
-                    <a:lstStyle/>
-                    <a:p>
-                      <a:pPr>
-                        <a:lnSpc>
-                          <a:spcPct val="100000"/>
-                        </a:lnSpc>
-                      </a:pPr>
-                      <a:r>
-                        <a:rPr sz="900" b="0">
-                          <a:solidFill>
-                            <a:srgbClr val="1A1A1A"/>
-                          </a:solidFill>
-                          <a:latin typeface="Calibri"/>
-                        </a:rPr>
-                        <a:t>same colour as other bright surfaces in RGB</a:t>
-                      </a:r>
-                    </a:p>
-                  </a:txBody>
-                  <a:tcPr anchor="ctr" marL="54864" marR="45720" marT="18288" marB="18288">
-                    <a:solidFill>
-                      <a:srgbClr val="F5F5F5"/>
-                    </a:solidFill>
-                  </a:tcPr>
-                </a:tc>
-              </a:tr>
-              <a:tr h="384048">
-                <a:tc>
-                  <a:txBody>
-                    <a:bodyPr/>
-                    <a:lstStyle/>
-                    <a:p>
-                      <a:pPr>
-                        <a:lnSpc>
-                          <a:spcPct val="100000"/>
-                        </a:lnSpc>
-                      </a:pPr>
-                      <a:r>
-                        <a:rPr sz="900" b="0">
-                          <a:solidFill>
-                            <a:srgbClr val="1A1A1A"/>
-                          </a:solidFill>
-                          <a:latin typeface="Calibri"/>
-                        </a:rPr>
-                        <a:t>Wood and firewood</a:t>
-                      </a:r>
-                    </a:p>
-                  </a:txBody>
-                  <a:tcPr anchor="ctr" marL="54864" marR="45720" marT="18288" marB="18288">
-                    <a:solidFill>
-                      <a:srgbClr val="FFFFFF"/>
-                    </a:solidFill>
-                  </a:tcPr>
-                </a:tc>
-                <a:tc>
-                  <a:txBody>
-                    <a:bodyPr/>
-                    <a:lstStyle/>
-                    <a:p>
-                      <a:pPr>
-                        <a:lnSpc>
-                          <a:spcPct val="100000"/>
-                        </a:lnSpc>
-                      </a:pPr>
-                      <a:r>
-                        <a:rPr sz="900" b="0">
-                          <a:solidFill>
-                            <a:srgbClr val="1A1A1A"/>
-                          </a:solidFill>
-                          <a:latin typeface="Calibri"/>
-                        </a:rPr>
-                        <a:t>yes</a:t>
-                      </a:r>
-                    </a:p>
-                  </a:txBody>
-                  <a:tcPr anchor="ctr" marL="54864" marR="45720" marT="18288" marB="18288">
-                    <a:solidFill>
-                      <a:srgbClr val="FFFFFF"/>
-                    </a:solidFill>
-                  </a:tcPr>
-                </a:tc>
-                <a:tc>
-                  <a:txBody>
-                    <a:bodyPr/>
-                    <a:lstStyle/>
-                    <a:p>
-                      <a:pPr>
-                        <a:lnSpc>
-                          <a:spcPct val="100000"/>
-                        </a:lnSpc>
-                      </a:pPr>
-                      <a:r>
-                        <a:rPr sz="900" b="0">
-                          <a:solidFill>
-                            <a:srgbClr val="1A1A1A"/>
-                          </a:solidFill>
-                          <a:latin typeface="Calibri"/>
-                        </a:rPr>
-                        <a:t>yes</a:t>
-                      </a:r>
-                    </a:p>
-                  </a:txBody>
-                  <a:tcPr anchor="ctr" marL="54864" marR="45720" marT="18288" marB="18288">
-                    <a:solidFill>
-                      <a:srgbClr val="FFFFFF"/>
-                    </a:solidFill>
-                  </a:tcPr>
-                </a:tc>
-                <a:tc>
-                  <a:txBody>
-                    <a:bodyPr/>
-                    <a:lstStyle/>
-                    <a:p>
-                      <a:pPr>
-                        <a:lnSpc>
-                          <a:spcPct val="100000"/>
-                        </a:lnSpc>
-                      </a:pPr>
-                      <a:r>
-                        <a:rPr sz="900" b="0">
-                          <a:solidFill>
-                            <a:srgbClr val="1A1A1A"/>
-                          </a:solidFill>
-                          <a:latin typeface="Calibri"/>
-                        </a:rPr>
-                        <a:t>confusable with soil and vegetation</a:t>
-                      </a:r>
-                    </a:p>
-                  </a:txBody>
-                  <a:tcPr anchor="ctr" marL="54864" marR="45720" marT="18288" marB="18288">
-                    <a:solidFill>
-                      <a:srgbClr val="FFFFFF"/>
-                    </a:solidFill>
-                  </a:tcPr>
-                </a:tc>
-              </a:tr>
-              <a:tr h="384048">
-                <a:tc>
-                  <a:txBody>
-                    <a:bodyPr/>
-                    <a:lstStyle/>
-                    <a:p>
-                      <a:pPr>
-                        <a:lnSpc>
-                          <a:spcPct val="100000"/>
-                        </a:lnSpc>
-                      </a:pPr>
-                      <a:r>
-                        <a:rPr sz="900" b="0">
-                          <a:solidFill>
-                            <a:srgbClr val="1A1A1A"/>
-                          </a:solidFill>
-                          <a:latin typeface="Calibri"/>
-                        </a:rPr>
-                        <a:t>Tires</a:t>
-                      </a:r>
-                    </a:p>
-                  </a:txBody>
-                  <a:tcPr anchor="ctr" marL="54864" marR="45720" marT="18288" marB="18288">
-                    <a:solidFill>
-                      <a:srgbClr val="F5F5F5"/>
-                    </a:solidFill>
-                  </a:tcPr>
-                </a:tc>
-                <a:tc>
-                  <a:txBody>
-                    <a:bodyPr/>
-                    <a:lstStyle/>
-                    <a:p>
-                      <a:pPr>
-                        <a:lnSpc>
-                          <a:spcPct val="100000"/>
-                        </a:lnSpc>
-                      </a:pPr>
-                      <a:r>
-                        <a:rPr sz="900" b="0">
-                          <a:solidFill>
-                            <a:srgbClr val="1A1A1A"/>
-                          </a:solidFill>
-                          <a:latin typeface="Calibri"/>
-                        </a:rPr>
-                        <a:t>yes</a:t>
-                      </a:r>
-                    </a:p>
-                  </a:txBody>
-                  <a:tcPr anchor="ctr" marL="54864" marR="45720" marT="18288" marB="18288">
-                    <a:solidFill>
-                      <a:srgbClr val="F5F5F5"/>
-                    </a:solidFill>
-                  </a:tcPr>
-                </a:tc>
-                <a:tc>
-                  <a:txBody>
-                    <a:bodyPr/>
-                    <a:lstStyle/>
-                    <a:p>
-                      <a:pPr>
-                        <a:lnSpc>
-                          <a:spcPct val="100000"/>
-                        </a:lnSpc>
-                      </a:pPr>
-                      <a:r>
-                        <a:rPr sz="900" b="0">
-                          <a:solidFill>
-                            <a:srgbClr val="1A1A1A"/>
-                          </a:solidFill>
-                          <a:latin typeface="Calibri"/>
-                        </a:rPr>
-                        <a:t>yes</a:t>
-                      </a:r>
-                    </a:p>
-                  </a:txBody>
-                  <a:tcPr anchor="ctr" marL="54864" marR="45720" marT="18288" marB="18288">
-                    <a:solidFill>
-                      <a:srgbClr val="F5F5F5"/>
-                    </a:solidFill>
-                  </a:tcPr>
-                </a:tc>
-                <a:tc>
-                  <a:txBody>
-                    <a:bodyPr/>
-                    <a:lstStyle/>
-                    <a:p>
-                      <a:pPr>
-                        <a:lnSpc>
-                          <a:spcPct val="100000"/>
-                        </a:lnSpc>
-                      </a:pPr>
-                      <a:r>
-                        <a:rPr sz="900" b="0">
-                          <a:solidFill>
-                            <a:srgbClr val="1A1A1A"/>
-                          </a:solidFill>
-                          <a:latin typeface="Calibri"/>
-                        </a:rPr>
-                        <a:t>dark target, low contrast</a:t>
-                      </a:r>
-                    </a:p>
-                  </a:txBody>
-                  <a:tcPr anchor="ctr" marL="54864" marR="45720" marT="18288" marB="18288">
-                    <a:solidFill>
-                      <a:srgbClr val="F5F5F5"/>
-                    </a:solidFill>
-                  </a:tcPr>
-                </a:tc>
-              </a:tr>
-              <a:tr h="384048">
-                <a:tc>
-                  <a:txBody>
-                    <a:bodyPr/>
-                    <a:lstStyle/>
-                    <a:p>
-                      <a:pPr>
-                        <a:lnSpc>
-                          <a:spcPct val="100000"/>
-                        </a:lnSpc>
-                      </a:pPr>
-                      <a:r>
-                        <a:rPr sz="900" b="0">
-                          <a:solidFill>
-                            <a:srgbClr val="1A1A1A"/>
-                          </a:solidFill>
-                          <a:latin typeface="Calibri"/>
-                        </a:rPr>
-                        <a:t>Asbestos-cement</a:t>
-                      </a:r>
-                    </a:p>
-                  </a:txBody>
-                  <a:tcPr anchor="ctr" marL="54864" marR="45720" marT="18288" marB="18288">
-                    <a:solidFill>
-                      <a:srgbClr val="FFFFFF"/>
-                    </a:solidFill>
-                  </a:tcPr>
-                </a:tc>
-                <a:tc>
-                  <a:txBody>
-                    <a:bodyPr/>
-                    <a:lstStyle/>
-                    <a:p>
-                      <a:pPr>
-                        <a:lnSpc>
-                          <a:spcPct val="100000"/>
-                        </a:lnSpc>
-                      </a:pPr>
-                      <a:r>
-                        <a:rPr sz="900" b="0">
-                          <a:solidFill>
-                            <a:srgbClr val="1A1A1A"/>
-                          </a:solidFill>
-                          <a:latin typeface="Calibri"/>
-                        </a:rPr>
-                        <a:t>yes</a:t>
-                      </a:r>
-                    </a:p>
-                  </a:txBody>
-                  <a:tcPr anchor="ctr" marL="54864" marR="45720" marT="18288" marB="18288">
-                    <a:solidFill>
-                      <a:srgbClr val="FFFFFF"/>
-                    </a:solidFill>
-                  </a:tcPr>
-                </a:tc>
-                <a:tc>
-                  <a:txBody>
-                    <a:bodyPr/>
-                    <a:lstStyle/>
-                    <a:p>
-                      <a:pPr>
-                        <a:lnSpc>
-                          <a:spcPct val="100000"/>
-                        </a:lnSpc>
-                      </a:pPr>
-                      <a:r>
-                        <a:rPr sz="900" b="0">
-                          <a:solidFill>
-                            <a:srgbClr val="1A1A1A"/>
-                          </a:solidFill>
-                          <a:latin typeface="Calibri"/>
-                        </a:rPr>
-                        <a:t>yes, dedicated pilot</a:t>
-                      </a:r>
-                    </a:p>
-                  </a:txBody>
-                  <a:tcPr anchor="ctr" marL="54864" marR="45720" marT="18288" marB="18288">
-                    <a:solidFill>
-                      <a:srgbClr val="FFFFFF"/>
-                    </a:solidFill>
-                  </a:tcPr>
-                </a:tc>
-                <a:tc>
-                  <a:txBody>
-                    <a:bodyPr/>
-                    <a:lstStyle/>
-                    <a:p>
-                      <a:pPr>
-                        <a:lnSpc>
-                          <a:spcPct val="100000"/>
-                        </a:lnSpc>
-                      </a:pPr>
-                      <a:r>
-                        <a:rPr sz="900" b="0">
-                          <a:solidFill>
-                            <a:srgbClr val="1A1A1A"/>
-                          </a:solidFill>
-                          <a:latin typeface="Calibri"/>
-                        </a:rPr>
-                        <a:t>public regional ground truth (WFS)</a:t>
-                      </a:r>
-                    </a:p>
-                  </a:txBody>
-                  <a:tcPr anchor="ctr" marL="54864" marR="45720" marT="18288" marB="18288">
-                    <a:solidFill>
-                      <a:srgbClr val="FFFFFF"/>
-                    </a:solidFill>
-                  </a:tcPr>
-                </a:tc>
-              </a:tr>
-              <a:tr h="384048">
-                <a:tc>
-                  <a:txBody>
-                    <a:bodyPr/>
-                    <a:lstStyle/>
-                    <a:p>
-                      <a:pPr>
-                        <a:lnSpc>
-                          <a:spcPct val="100000"/>
-                        </a:lnSpc>
-                      </a:pPr>
-                      <a:r>
-                        <a:rPr sz="900" b="0">
-                          <a:solidFill>
-                            <a:srgbClr val="1A1A1A"/>
-                          </a:solidFill>
-                          <a:latin typeface="Calibri"/>
-                        </a:rPr>
-                        <a:t>Vehicles, tanks, containers</a:t>
-                      </a:r>
-                    </a:p>
-                  </a:txBody>
-                  <a:tcPr anchor="ctr" marL="54864" marR="45720" marT="18288" marB="18288">
-                    <a:solidFill>
-                      <a:srgbClr val="F5F5F5"/>
-                    </a:solidFill>
-                  </a:tcPr>
-                </a:tc>
-                <a:tc>
-                  <a:txBody>
-                    <a:bodyPr/>
-                    <a:lstStyle/>
-                    <a:p>
-                      <a:pPr>
-                        <a:lnSpc>
-                          <a:spcPct val="100000"/>
-                        </a:lnSpc>
-                      </a:pPr>
-                      <a:r>
-                        <a:rPr sz="900" b="0">
-                          <a:solidFill>
-                            <a:srgbClr val="1A1A1A"/>
-                          </a:solidFill>
-                          <a:latin typeface="Calibri"/>
-                        </a:rPr>
-                        <a:t>yes</a:t>
-                      </a:r>
-                    </a:p>
-                  </a:txBody>
-                  <a:tcPr anchor="ctr" marL="54864" marR="45720" marT="18288" marB="18288">
+                  <a:tcPr anchor="ctr" marL="45720" marR="36576" marT="18288" marB="18288">
                     <a:solidFill>
                       <a:srgbClr val="F5F5F5"/>
                     </a:solidFill>
@@ -5595,227 +5400,7 @@
                       </a:r>
                     </a:p>
                   </a:txBody>
-                  <a:tcPr anchor="ctr" marL="54864" marR="45720" marT="18288" marB="18288">
-                    <a:solidFill>
-                      <a:srgbClr val="F5F5F5"/>
-                    </a:solidFill>
-                  </a:tcPr>
-                </a:tc>
-                <a:tc>
-                  <a:txBody>
-                    <a:bodyPr/>
-                    <a:lstStyle/>
-                    <a:p>
-                      <a:pPr>
-                        <a:lnSpc>
-                          <a:spcPct val="100000"/>
-                        </a:lnSpc>
-                      </a:pPr>
-                      <a:r>
-                        <a:rPr sz="900" b="0">
-                          <a:solidFill>
-                            <a:srgbClr val="1A1A1A"/>
-                          </a:solidFill>
-                          <a:latin typeface="Calibri"/>
-                        </a:rPr>
-                        <a:t>shape-based, RGB sufficient in literature</a:t>
-                      </a:r>
-                    </a:p>
-                  </a:txBody>
-                  <a:tcPr anchor="ctr" marL="54864" marR="45720" marT="18288" marB="18288">
-                    <a:solidFill>
-                      <a:srgbClr val="F5F5F5"/>
-                    </a:solidFill>
-                  </a:tcPr>
-                </a:tc>
-              </a:tr>
-              <a:tr h="384048">
-                <a:tc>
-                  <a:txBody>
-                    <a:bodyPr/>
-                    <a:lstStyle/>
-                    <a:p>
-                      <a:pPr>
-                        <a:lnSpc>
-                          <a:spcPct val="100000"/>
-                        </a:lnSpc>
-                      </a:pPr>
-                      <a:r>
-                        <a:rPr sz="900" b="0">
-                          <a:solidFill>
-                            <a:srgbClr val="1A1A1A"/>
-                          </a:solidFill>
-                          <a:latin typeface="Calibri"/>
-                        </a:rPr>
-                        <a:t>Scrap, bulky items, big bags</a:t>
-                      </a:r>
-                    </a:p>
-                  </a:txBody>
-                  <a:tcPr anchor="ctr" marL="54864" marR="45720" marT="18288" marB="18288">
-                    <a:solidFill>
-                      <a:srgbClr val="FFFFFF"/>
-                    </a:solidFill>
-                  </a:tcPr>
-                </a:tc>
-                <a:tc>
-                  <a:txBody>
-                    <a:bodyPr/>
-                    <a:lstStyle/>
-                    <a:p>
-                      <a:pPr>
-                        <a:lnSpc>
-                          <a:spcPct val="100000"/>
-                        </a:lnSpc>
-                      </a:pPr>
-                      <a:r>
-                        <a:rPr sz="900" b="0">
-                          <a:solidFill>
-                            <a:srgbClr val="1A1A1A"/>
-                          </a:solidFill>
-                          <a:latin typeface="Calibri"/>
-                        </a:rPr>
-                        <a:t>yes</a:t>
-                      </a:r>
-                    </a:p>
-                  </a:txBody>
-                  <a:tcPr anchor="ctr" marL="54864" marR="45720" marT="18288" marB="18288">
-                    <a:solidFill>
-                      <a:srgbClr val="FFFFFF"/>
-                    </a:solidFill>
-                  </a:tcPr>
-                </a:tc>
-                <a:tc>
-                  <a:txBody>
-                    <a:bodyPr/>
-                    <a:lstStyle/>
-                    <a:p>
-                      <a:pPr>
-                        <a:lnSpc>
-                          <a:spcPct val="100000"/>
-                        </a:lnSpc>
-                      </a:pPr>
-                      <a:r>
-                        <a:rPr sz="900" b="0">
-                          <a:solidFill>
-                            <a:srgbClr val="1A1A1A"/>
-                          </a:solidFill>
-                          <a:latin typeface="Calibri"/>
-                        </a:rPr>
-                        <a:t>no</a:t>
-                      </a:r>
-                    </a:p>
-                  </a:txBody>
-                  <a:tcPr anchor="ctr" marL="54864" marR="45720" marT="18288" marB="18288">
-                    <a:solidFill>
-                      <a:srgbClr val="FFFFFF"/>
-                    </a:solidFill>
-                  </a:tcPr>
-                </a:tc>
-                <a:tc>
-                  <a:txBody>
-                    <a:bodyPr/>
-                    <a:lstStyle/>
-                    <a:p>
-                      <a:pPr>
-                        <a:lnSpc>
-                          <a:spcPct val="100000"/>
-                        </a:lnSpc>
-                      </a:pPr>
-                      <a:r>
-                        <a:rPr sz="900" b="0">
-                          <a:solidFill>
-                            <a:srgbClr val="1A1A1A"/>
-                          </a:solidFill>
-                          <a:latin typeface="Calibri"/>
-                        </a:rPr>
-                        <a:t>shape-based, few spectral cues expected</a:t>
-                      </a:r>
-                    </a:p>
-                  </a:txBody>
-                  <a:tcPr anchor="ctr" marL="54864" marR="45720" marT="18288" marB="18288">
-                    <a:solidFill>
-                      <a:srgbClr val="FFFFFF"/>
-                    </a:solidFill>
-                  </a:tcPr>
-                </a:tc>
-              </a:tr>
-              <a:tr h="384048">
-                <a:tc>
-                  <a:txBody>
-                    <a:bodyPr/>
-                    <a:lstStyle/>
-                    <a:p>
-                      <a:pPr>
-                        <a:lnSpc>
-                          <a:spcPct val="100000"/>
-                        </a:lnSpc>
-                      </a:pPr>
-                      <a:r>
-                        <a:rPr sz="900" b="0">
-                          <a:solidFill>
-                            <a:srgbClr val="1A1A1A"/>
-                          </a:solidFill>
-                          <a:latin typeface="Calibri"/>
-                        </a:rPr>
-                        <a:t>Sludge, foundry waste</a:t>
-                      </a:r>
-                    </a:p>
-                  </a:txBody>
-                  <a:tcPr anchor="ctr" marL="54864" marR="45720" marT="18288" marB="18288">
-                    <a:solidFill>
-                      <a:srgbClr val="F5F5F5"/>
-                    </a:solidFill>
-                  </a:tcPr>
-                </a:tc>
-                <a:tc>
-                  <a:txBody>
-                    <a:bodyPr/>
-                    <a:lstStyle/>
-                    <a:p>
-                      <a:pPr>
-                        <a:lnSpc>
-                          <a:spcPct val="100000"/>
-                        </a:lnSpc>
-                      </a:pPr>
-                      <a:r>
-                        <a:rPr sz="900" b="0">
-                          <a:solidFill>
-                            <a:srgbClr val="1A1A1A"/>
-                          </a:solidFill>
-                          <a:latin typeface="Calibri"/>
-                        </a:rPr>
-                        <a:t>yes</a:t>
-                      </a:r>
-                    </a:p>
-                  </a:txBody>
-                  <a:tcPr anchor="ctr" marL="54864" marR="45720" marT="18288" marB="18288">
-                    <a:solidFill>
-                      <a:srgbClr val="F5F5F5"/>
-                    </a:solidFill>
-                  </a:tcPr>
-                </a:tc>
-                <a:tc>
-                  <a:txBody>
-                    <a:bodyPr/>
-                    <a:lstStyle/>
-                    <a:p>
-                      <a:pPr>
-                        <a:lnSpc>
-                          <a:spcPct val="100000"/>
-                        </a:lnSpc>
-                      </a:pPr>
-                      <a:r>
-                        <a:rPr sz="900" b="0">
-                          <a:solidFill>
-                            <a:srgbClr val="1A1A1A"/>
-                          </a:solidFill>
-                          <a:latin typeface="Calibri"/>
-                        </a:rPr>
-                        <a:t>no</a:t>
-                      </a:r>
-                    </a:p>
-                  </a:txBody>
-                  <a:tcPr anchor="ctr" marL="54864" marR="45720" marT="18288" marB="18288">
+                  <a:tcPr anchor="ctr" marL="45720" marR="36576" marT="18288" marB="18288">
                     <a:solidFill>
                       <a:srgbClr val="F5F5F5"/>
                     </a:solidFill>
@@ -5842,7 +5427,7 @@
                       </a:r>
                     </a:p>
                   </a:txBody>
-                  <a:tcPr anchor="ctr" marL="54864" marR="45720" marT="18288" marB="18288">
+                  <a:tcPr anchor="ctr" marL="45720" marR="36576" marT="18288" marB="18288">
                     <a:solidFill>
                       <a:srgbClr val="F5F5F5"/>
                     </a:solidFill>
@@ -5855,13 +5440,13 @@
       </p:graphicFrame>
       <p:sp>
         <p:nvSpPr>
-          <p:cNvPr id="4" name="TextBox 3"/>
+          <p:cNvPr id="5" name="TextBox 4"/>
           <p:cNvSpPr txBox="1"/>
           <p:nvPr/>
         </p:nvSpPr>
         <p:spPr>
           <a:xfrm>
-            <a:off x="411480" y="4791456"/>
+            <a:off x="411480" y="4809744"/>
             <a:ext cx="8321040" cy="237744"/>
           </a:xfrm>
           <a:prstGeom prst="rect">
@@ -5877,7 +5462,7 @@
           <a:p>
             <a:pPr algn="l">
               <a:lnSpc>
-                <a:spcPct val="115000"/>
+                <a:spcPct val="112000"/>
               </a:lnSpc>
               <a:spcAft>
                 <a:spcPts val="0"/>
@@ -5890,20 +5475,20 @@
                 </a:solidFill>
                 <a:latin typeface="Calibri"/>
               </a:rPr>
-              <a:t>13 categories, same taxonomy as Alari 2024. All remain classification targets; the band ablation focuses on the ambiguous subset.</a:t>
-            </a:r>
-          </a:p>
-        </p:txBody>
-      </p:sp>
-      <p:sp>
-        <p:nvSpPr>
-          <p:cNvPr id="5" name="TextBox 4"/>
+              <a:t>13 categories, taxonomy and samples from Alari 2024 (politesi 10589/230633). Band ablation focuses on the ambiguous subset.</a:t>
+            </a:r>
+          </a:p>
+        </p:txBody>
+      </p:sp>
+      <p:sp>
+        <p:nvSpPr>
+          <p:cNvPr id="6" name="TextBox 5"/>
           <p:cNvSpPr txBox="1"/>
           <p:nvPr/>
         </p:nvSpPr>
         <p:spPr>
           <a:xfrm>
-            <a:off x="91440" y="4791456"/>
+            <a:off x="91440" y="4809744"/>
             <a:ext cx="411480" cy="256032"/>
           </a:xfrm>
           <a:prstGeom prst="rect">
@@ -5956,8 +5541,8 @@
         </p:nvSpPr>
         <p:spPr>
           <a:xfrm>
-            <a:off x="411480" y="274320"/>
-            <a:ext cx="8321040" cy="594360"/>
+            <a:off x="411480" y="256032"/>
+            <a:ext cx="8321040" cy="548640"/>
           </a:xfrm>
           <a:prstGeom prst="rect">
             <a:avLst/>
@@ -5972,7 +5557,7 @@
           <a:p>
             <a:pPr algn="l">
               <a:lnSpc>
-                <a:spcPct val="115000"/>
+                <a:spcPct val="112000"/>
               </a:lnSpc>
               <a:spcAft>
                 <a:spcPts val="600"/>
@@ -5998,8 +5583,8 @@
         </p:nvSpPr>
         <p:spPr>
           <a:xfrm>
-            <a:off x="411480" y="1005840"/>
-            <a:ext cx="8321040" cy="2011680"/>
+            <a:off x="411480" y="960120"/>
+            <a:ext cx="8321040" cy="914400"/>
           </a:xfrm>
           <a:prstGeom prst="rect">
             <a:avLst/>
@@ -6007,84 +5592,27 @@
           <a:noFill/>
         </p:spPr>
         <p:txBody>
-          <a:bodyPr wrap="square" anchor="ctr">
+          <a:bodyPr wrap="square">
             <a:spAutoFit/>
           </a:bodyPr>
           <a:lstStyle/>
           <a:p>
             <a:pPr algn="l">
               <a:lnSpc>
-                <a:spcPct val="115000"/>
+                <a:spcPct val="112000"/>
               </a:lnSpc>
               <a:spcAft>
                 <a:spcPts val="600"/>
               </a:spcAft>
             </a:pPr>
             <a:r>
-              <a:rPr sz="1300" b="0" i="0">
+              <a:rPr sz="1250" b="0" i="0">
                 <a:solidFill>
                   <a:srgbClr val="1A1A1A"/>
                 </a:solidFill>
                 <a:latin typeface="Calibri"/>
               </a:rPr>
-              <a:t>Scripted queries on the Scopus API, two query sets: waste detection in remote sensing; asbestos roof mapping.</a:t>
-            </a:r>
-          </a:p>
-          <a:p>
-            <a:pPr algn="l">
-              <a:lnSpc>
-                <a:spcPct val="115000"/>
-              </a:lnSpc>
-              <a:spcAft>
-                <a:spcPts val="600"/>
-              </a:spcAft>
-            </a:pPr>
-            <a:r>
-              <a:rPr sz="1300" b="0" i="0">
-                <a:solidFill>
-                  <a:srgbClr val="1A1A1A"/>
-                </a:solidFill>
-                <a:latin typeface="Calibri"/>
-              </a:rPr>
-              <a:t>After deduplication: 699 unique records (622 waste, 77 asbestos).</a:t>
-            </a:r>
-          </a:p>
-          <a:p>
-            <a:pPr algn="l">
-              <a:lnSpc>
-                <a:spcPct val="115000"/>
-              </a:lnSpc>
-              <a:spcAft>
-                <a:spcPts val="600"/>
-              </a:spcAft>
-            </a:pPr>
-            <a:r>
-              <a:rPr sz="1300" b="0" i="0">
-                <a:solidFill>
-                  <a:srgbClr val="1A1A1A"/>
-                </a:solidFill>
-                <a:latin typeface="Calibri"/>
-              </a:rPr>
-              <a:t>Screening criteria: task pertinence (terrestrial waste or roof materials), GSD compatible with the task, recency and citations, peer review. Snowballing from the Fraternali 2024 survey and from the Alari 2024 thesis references.</a:t>
-            </a:r>
-          </a:p>
-          <a:p>
-            <a:pPr algn="l">
-              <a:lnSpc>
-                <a:spcPct val="115000"/>
-              </a:lnSpc>
-              <a:spcAft>
-                <a:spcPts val="600"/>
-              </a:spcAft>
-            </a:pPr>
-            <a:r>
-              <a:rPr sz="1300" b="0" i="0">
-                <a:solidFill>
-                  <a:srgbClr val="1A1A1A"/>
-                </a:solidFill>
-                <a:latin typeface="Calibri"/>
-              </a:rPr>
-              <a:t>Result: a curated library of 47 papers with structured notes, synchronised with the team Excel. 13 works are cited in this deck.</a:t>
+              <a:t>Scripted queries on the Scopus API (waste detection in remote sensing; asbestos roof mapping), deduplication, manual screening with explicit criteria, snowballing from the Fraternali 2024 survey and the Alari 2024 references.</a:t>
             </a:r>
           </a:p>
         </p:txBody>
@@ -6105,8 +5633,8 @@
         </p:blipFill>
         <p:spPr>
           <a:xfrm>
-            <a:off x="1693147" y="3063240"/>
-            <a:ext cx="5757705" cy="1600200"/>
+            <a:off x="502920" y="2000928"/>
+            <a:ext cx="8138160" cy="2261783"/>
           </a:xfrm>
           <a:prstGeom prst="rect">
             <a:avLst/>
@@ -6121,7 +5649,7 @@
         </p:nvSpPr>
         <p:spPr>
           <a:xfrm>
-            <a:off x="411480" y="4791456"/>
+            <a:off x="411480" y="4809744"/>
             <a:ext cx="8321040" cy="237744"/>
           </a:xfrm>
           <a:prstGeom prst="rect">
@@ -6137,7 +5665,7 @@
           <a:p>
             <a:pPr algn="l">
               <a:lnSpc>
-                <a:spcPct val="115000"/>
+                <a:spcPct val="112000"/>
               </a:lnSpc>
               <a:spcAft>
                 <a:spcPts val="0"/>
@@ -6163,7 +5691,7 @@
         </p:nvSpPr>
         <p:spPr>
           <a:xfrm>
-            <a:off x="91440" y="4791456"/>
+            <a:off x="91440" y="4809744"/>
             <a:ext cx="411480" cy="256032"/>
           </a:xfrm>
           <a:prstGeom prst="rect">
@@ -6216,8 +5744,8 @@
         </p:nvSpPr>
         <p:spPr>
           <a:xfrm>
-            <a:off x="411480" y="274320"/>
-            <a:ext cx="8321040" cy="594360"/>
+            <a:off x="411480" y="256032"/>
+            <a:ext cx="8321040" cy="548640"/>
           </a:xfrm>
           <a:prstGeom prst="rect">
             <a:avLst/>
@@ -6232,7 +5760,7 @@
           <a:p>
             <a:pPr algn="l">
               <a:lnSpc>
-                <a:spcPct val="115000"/>
+                <a:spcPct val="112000"/>
               </a:lnSpc>
               <a:spcAft>
                 <a:spcPts val="600"/>
@@ -6297,7 +5825,7 @@
                       </a:r>
                     </a:p>
                   </a:txBody>
-                  <a:tcPr anchor="ctr" marL="54864" marR="45720" marT="18288" marB="18288">
+                  <a:tcPr anchor="ctr" marL="45720" marR="36576" marT="18288" marB="18288">
                     <a:solidFill>
                       <a:srgbClr val="DDDDDD"/>
                     </a:solidFill>
@@ -6324,7 +5852,7 @@
                       </a:r>
                     </a:p>
                   </a:txBody>
-                  <a:tcPr anchor="ctr" marL="54864" marR="45720" marT="18288" marB="18288">
+                  <a:tcPr anchor="ctr" marL="45720" marR="36576" marT="18288" marB="18288">
                     <a:solidFill>
                       <a:srgbClr val="DDDDDD"/>
                     </a:solidFill>
@@ -6351,7 +5879,7 @@
                       </a:r>
                     </a:p>
                   </a:txBody>
-                  <a:tcPr anchor="ctr" marL="54864" marR="45720" marT="18288" marB="18288">
+                  <a:tcPr anchor="ctr" marL="45720" marR="36576" marT="18288" marB="18288">
                     <a:solidFill>
                       <a:srgbClr val="DDDDDD"/>
                     </a:solidFill>
@@ -6378,7 +5906,7 @@
                       </a:r>
                     </a:p>
                   </a:txBody>
-                  <a:tcPr anchor="ctr" marL="54864" marR="45720" marT="18288" marB="18288">
+                  <a:tcPr anchor="ctr" marL="45720" marR="36576" marT="18288" marB="18288">
                     <a:solidFill>
                       <a:srgbClr val="DDDDDD"/>
                     </a:solidFill>
@@ -6405,7 +5933,7 @@
                       </a:r>
                     </a:p>
                   </a:txBody>
-                  <a:tcPr anchor="ctr" marL="54864" marR="45720" marT="18288" marB="18288">
+                  <a:tcPr anchor="ctr" marL="45720" marR="36576" marT="18288" marB="18288">
                     <a:solidFill>
                       <a:srgbClr val="DDDDDD"/>
                     </a:solidFill>
@@ -6434,7 +5962,7 @@
                       </a:r>
                     </a:p>
                   </a:txBody>
-                  <a:tcPr anchor="ctr" marL="54864" marR="45720" marT="18288" marB="18288">
+                  <a:tcPr anchor="ctr" marL="45720" marR="36576" marT="18288" marB="18288">
                     <a:solidFill>
                       <a:srgbClr val="FFFFFF"/>
                     </a:solidFill>
@@ -6461,7 +5989,7 @@
                       </a:r>
                     </a:p>
                   </a:txBody>
-                  <a:tcPr anchor="ctr" marL="54864" marR="45720" marT="18288" marB="18288">
+                  <a:tcPr anchor="ctr" marL="45720" marR="36576" marT="18288" marB="18288">
                     <a:solidFill>
                       <a:srgbClr val="FFFFFF"/>
                     </a:solidFill>
@@ -6488,7 +6016,7 @@
                       </a:r>
                     </a:p>
                   </a:txBody>
-                  <a:tcPr anchor="ctr" marL="54864" marR="45720" marT="18288" marB="18288">
+                  <a:tcPr anchor="ctr" marL="45720" marR="36576" marT="18288" marB="18288">
                     <a:solidFill>
                       <a:srgbClr val="FFFFFF"/>
                     </a:solidFill>
@@ -6515,7 +6043,7 @@
                       </a:r>
                     </a:p>
                   </a:txBody>
-                  <a:tcPr anchor="ctr" marL="54864" marR="45720" marT="18288" marB="18288">
+                  <a:tcPr anchor="ctr" marL="45720" marR="36576" marT="18288" marB="18288">
                     <a:solidFill>
                       <a:srgbClr val="FFFFFF"/>
                     </a:solidFill>
@@ -6542,7 +6070,7 @@
                       </a:r>
                     </a:p>
                   </a:txBody>
-                  <a:tcPr anchor="ctr" marL="54864" marR="45720" marT="18288" marB="18288">
+                  <a:tcPr anchor="ctr" marL="45720" marR="36576" marT="18288" marB="18288">
                     <a:solidFill>
                       <a:srgbClr val="FFFFFF"/>
                     </a:solidFill>
@@ -6571,7 +6099,7 @@
                       </a:r>
                     </a:p>
                   </a:txBody>
-                  <a:tcPr anchor="ctr" marL="54864" marR="45720" marT="18288" marB="18288">
+                  <a:tcPr anchor="ctr" marL="45720" marR="36576" marT="18288" marB="18288">
                     <a:solidFill>
                       <a:srgbClr val="F5F5F5"/>
                     </a:solidFill>
@@ -6598,7 +6126,7 @@
                       </a:r>
                     </a:p>
                   </a:txBody>
-                  <a:tcPr anchor="ctr" marL="54864" marR="45720" marT="18288" marB="18288">
+                  <a:tcPr anchor="ctr" marL="45720" marR="36576" marT="18288" marB="18288">
                     <a:solidFill>
                       <a:srgbClr val="F5F5F5"/>
                     </a:solidFill>
@@ -6625,7 +6153,7 @@
                       </a:r>
                     </a:p>
                   </a:txBody>
-                  <a:tcPr anchor="ctr" marL="54864" marR="45720" marT="18288" marB="18288">
+                  <a:tcPr anchor="ctr" marL="45720" marR="36576" marT="18288" marB="18288">
                     <a:solidFill>
                       <a:srgbClr val="F5F5F5"/>
                     </a:solidFill>
@@ -6652,7 +6180,7 @@
                       </a:r>
                     </a:p>
                   </a:txBody>
-                  <a:tcPr anchor="ctr" marL="54864" marR="45720" marT="18288" marB="18288">
+                  <a:tcPr anchor="ctr" marL="45720" marR="36576" marT="18288" marB="18288">
                     <a:solidFill>
                       <a:srgbClr val="F5F5F5"/>
                     </a:solidFill>
@@ -6679,7 +6207,7 @@
                       </a:r>
                     </a:p>
                   </a:txBody>
-                  <a:tcPr anchor="ctr" marL="54864" marR="45720" marT="18288" marB="18288">
+                  <a:tcPr anchor="ctr" marL="45720" marR="36576" marT="18288" marB="18288">
                     <a:solidFill>
                       <a:srgbClr val="F5F5F5"/>
                     </a:solidFill>
@@ -6708,7 +6236,7 @@
                       </a:r>
                     </a:p>
                   </a:txBody>
-                  <a:tcPr anchor="ctr" marL="54864" marR="45720" marT="18288" marB="18288">
+                  <a:tcPr anchor="ctr" marL="45720" marR="36576" marT="18288" marB="18288">
                     <a:solidFill>
                       <a:srgbClr val="FFFFFF"/>
                     </a:solidFill>
@@ -6735,7 +6263,7 @@
                       </a:r>
                     </a:p>
                   </a:txBody>
-                  <a:tcPr anchor="ctr" marL="54864" marR="45720" marT="18288" marB="18288">
+                  <a:tcPr anchor="ctr" marL="45720" marR="36576" marT="18288" marB="18288">
                     <a:solidFill>
                       <a:srgbClr val="FFFFFF"/>
                     </a:solidFill>
@@ -6762,7 +6290,7 @@
                       </a:r>
                     </a:p>
                   </a:txBody>
-                  <a:tcPr anchor="ctr" marL="54864" marR="45720" marT="18288" marB="18288">
+                  <a:tcPr anchor="ctr" marL="45720" marR="36576" marT="18288" marB="18288">
                     <a:solidFill>
                       <a:srgbClr val="FFFFFF"/>
                     </a:solidFill>
@@ -6789,7 +6317,7 @@
                       </a:r>
                     </a:p>
                   </a:txBody>
-                  <a:tcPr anchor="ctr" marL="54864" marR="45720" marT="18288" marB="18288">
+                  <a:tcPr anchor="ctr" marL="45720" marR="36576" marT="18288" marB="18288">
                     <a:solidFill>
                       <a:srgbClr val="FFFFFF"/>
                     </a:solidFill>
@@ -6816,7 +6344,7 @@
                       </a:r>
                     </a:p>
                   </a:txBody>
-                  <a:tcPr anchor="ctr" marL="54864" marR="45720" marT="18288" marB="18288">
+                  <a:tcPr anchor="ctr" marL="45720" marR="36576" marT="18288" marB="18288">
                     <a:solidFill>
                       <a:srgbClr val="FFFFFF"/>
                     </a:solidFill>
@@ -6845,7 +6373,7 @@
                       </a:r>
                     </a:p>
                   </a:txBody>
-                  <a:tcPr anchor="ctr" marL="54864" marR="45720" marT="18288" marB="18288">
+                  <a:tcPr anchor="ctr" marL="45720" marR="36576" marT="18288" marB="18288">
                     <a:solidFill>
                       <a:srgbClr val="F5F5F5"/>
                     </a:solidFill>
@@ -6872,7 +6400,7 @@
                       </a:r>
                     </a:p>
                   </a:txBody>
-                  <a:tcPr anchor="ctr" marL="54864" marR="45720" marT="18288" marB="18288">
+                  <a:tcPr anchor="ctr" marL="45720" marR="36576" marT="18288" marB="18288">
                     <a:solidFill>
                       <a:srgbClr val="F5F5F5"/>
                     </a:solidFill>
@@ -6899,7 +6427,7 @@
                       </a:r>
                     </a:p>
                   </a:txBody>
-                  <a:tcPr anchor="ctr" marL="54864" marR="45720" marT="18288" marB="18288">
+                  <a:tcPr anchor="ctr" marL="45720" marR="36576" marT="18288" marB="18288">
                     <a:solidFill>
                       <a:srgbClr val="F5F5F5"/>
                     </a:solidFill>
@@ -6926,7 +6454,7 @@
                       </a:r>
                     </a:p>
                   </a:txBody>
-                  <a:tcPr anchor="ctr" marL="54864" marR="45720" marT="18288" marB="18288">
+                  <a:tcPr anchor="ctr" marL="45720" marR="36576" marT="18288" marB="18288">
                     <a:solidFill>
                       <a:srgbClr val="F5F5F5"/>
                     </a:solidFill>
@@ -6953,7 +6481,7 @@
                       </a:r>
                     </a:p>
                   </a:txBody>
-                  <a:tcPr anchor="ctr" marL="54864" marR="45720" marT="18288" marB="18288">
+                  <a:tcPr anchor="ctr" marL="45720" marR="36576" marT="18288" marB="18288">
                     <a:solidFill>
                       <a:srgbClr val="F5F5F5"/>
                     </a:solidFill>
@@ -6982,7 +6510,7 @@
                       </a:r>
                     </a:p>
                   </a:txBody>
-                  <a:tcPr anchor="ctr" marL="54864" marR="45720" marT="18288" marB="18288">
+                  <a:tcPr anchor="ctr" marL="45720" marR="36576" marT="18288" marB="18288">
                     <a:solidFill>
                       <a:srgbClr val="FFFFFF"/>
                     </a:solidFill>
@@ -7009,7 +6537,7 @@
                       </a:r>
                     </a:p>
                   </a:txBody>
-                  <a:tcPr anchor="ctr" marL="54864" marR="45720" marT="18288" marB="18288">
+                  <a:tcPr anchor="ctr" marL="45720" marR="36576" marT="18288" marB="18288">
                     <a:solidFill>
                       <a:srgbClr val="FFFFFF"/>
                     </a:solidFill>
@@ -7036,7 +6564,7 @@
                       </a:r>
                     </a:p>
                   </a:txBody>
-                  <a:tcPr anchor="ctr" marL="54864" marR="45720" marT="18288" marB="18288">
+                  <a:tcPr anchor="ctr" marL="45720" marR="36576" marT="18288" marB="18288">
                     <a:solidFill>
                       <a:srgbClr val="FFFFFF"/>
                     </a:solidFill>
@@ -7063,7 +6591,7 @@
                       </a:r>
                     </a:p>
                   </a:txBody>
-                  <a:tcPr anchor="ctr" marL="54864" marR="45720" marT="18288" marB="18288">
+                  <a:tcPr anchor="ctr" marL="45720" marR="36576" marT="18288" marB="18288">
                     <a:solidFill>
                       <a:srgbClr val="FFFFFF"/>
                     </a:solidFill>
@@ -7090,7 +6618,7 @@
                       </a:r>
                     </a:p>
                   </a:txBody>
-                  <a:tcPr anchor="ctr" marL="54864" marR="45720" marT="18288" marB="18288">
+                  <a:tcPr anchor="ctr" marL="45720" marR="36576" marT="18288" marB="18288">
                     <a:solidFill>
                       <a:srgbClr val="FFFFFF"/>
                     </a:solidFill>
@@ -7119,7 +6647,7 @@
                       </a:r>
                     </a:p>
                   </a:txBody>
-                  <a:tcPr anchor="ctr" marL="54864" marR="45720" marT="18288" marB="18288">
+                  <a:tcPr anchor="ctr" marL="45720" marR="36576" marT="18288" marB="18288">
                     <a:solidFill>
                       <a:srgbClr val="F5F5F5"/>
                     </a:solidFill>
@@ -7146,7 +6674,7 @@
                       </a:r>
                     </a:p>
                   </a:txBody>
-                  <a:tcPr anchor="ctr" marL="54864" marR="45720" marT="18288" marB="18288">
+                  <a:tcPr anchor="ctr" marL="45720" marR="36576" marT="18288" marB="18288">
                     <a:solidFill>
                       <a:srgbClr val="F5F5F5"/>
                     </a:solidFill>
@@ -7173,7 +6701,7 @@
                       </a:r>
                     </a:p>
                   </a:txBody>
-                  <a:tcPr anchor="ctr" marL="54864" marR="45720" marT="18288" marB="18288">
+                  <a:tcPr anchor="ctr" marL="45720" marR="36576" marT="18288" marB="18288">
                     <a:solidFill>
                       <a:srgbClr val="F5F5F5"/>
                     </a:solidFill>
@@ -7200,7 +6728,7 @@
                       </a:r>
                     </a:p>
                   </a:txBody>
-                  <a:tcPr anchor="ctr" marL="54864" marR="45720" marT="18288" marB="18288">
+                  <a:tcPr anchor="ctr" marL="45720" marR="36576" marT="18288" marB="18288">
                     <a:solidFill>
                       <a:srgbClr val="F5F5F5"/>
                     </a:solidFill>
@@ -7227,7 +6755,7 @@
                       </a:r>
                     </a:p>
                   </a:txBody>
-                  <a:tcPr anchor="ctr" marL="54864" marR="45720" marT="18288" marB="18288">
+                  <a:tcPr anchor="ctr" marL="45720" marR="36576" marT="18288" marB="18288">
                     <a:solidFill>
                       <a:srgbClr val="F5F5F5"/>
                     </a:solidFill>
@@ -7246,7 +6774,7 @@
         </p:nvSpPr>
         <p:spPr>
           <a:xfrm>
-            <a:off x="411480" y="4791456"/>
+            <a:off x="411480" y="4809744"/>
             <a:ext cx="8321040" cy="237744"/>
           </a:xfrm>
           <a:prstGeom prst="rect">
@@ -7262,7 +6790,7 @@
           <a:p>
             <a:pPr algn="l">
               <a:lnSpc>
-                <a:spcPct val="115000"/>
+                <a:spcPct val="112000"/>
               </a:lnSpc>
               <a:spcAft>
                 <a:spcPts val="0"/>
@@ -7288,7 +6816,7 @@
         </p:nvSpPr>
         <p:spPr>
           <a:xfrm>
-            <a:off x="91440" y="4791456"/>
+            <a:off x="91440" y="4809744"/>
             <a:ext cx="411480" cy="256032"/>
           </a:xfrm>
           <a:prstGeom prst="rect">
@@ -7341,8 +6869,8 @@
         </p:nvSpPr>
         <p:spPr>
           <a:xfrm>
-            <a:off x="411480" y="274320"/>
-            <a:ext cx="8321040" cy="594360"/>
+            <a:off x="411480" y="256032"/>
+            <a:ext cx="8321040" cy="548640"/>
           </a:xfrm>
           <a:prstGeom prst="rect">
             <a:avLst/>
@@ -7357,7 +6885,7 @@
           <a:p>
             <a:pPr algn="l">
               <a:lnSpc>
-                <a:spcPct val="115000"/>
+                <a:spcPct val="112000"/>
               </a:lnSpc>
               <a:spcAft>
                 <a:spcPts val="600"/>
@@ -7384,8 +6912,8 @@
           <p:nvPr/>
         </p:nvGraphicFramePr>
         <p:xfrm>
-          <a:off x="411480" y="1632204"/>
-          <a:ext cx="8321039" cy="2450592"/>
+          <a:off x="411480" y="1188720"/>
+          <a:ext cx="5806440" cy="2340864"/>
         </p:xfrm>
         <a:graphic>
           <a:graphicData uri="http://schemas.openxmlformats.org/drawingml/2006/table">
@@ -7394,13 +6922,12 @@
                 <a:tableStyleId>{5C22544A-7EE6-4342-B048-85BDC9FD1C3A}</a:tableStyleId>
               </a:tblPr>
               <a:tblGrid>
-                <a:gridCol w="1874519"/>
-                <a:gridCol w="1691640"/>
-                <a:gridCol w="1325880"/>
-                <a:gridCol w="1783080"/>
-                <a:gridCol w="1645920"/>
+                <a:gridCol w="1600200"/>
+                <a:gridCol w="1463040"/>
+                <a:gridCol w="1188720"/>
+                <a:gridCol w="1554480"/>
               </a:tblGrid>
-              <a:tr h="347472">
+              <a:tr h="329184">
                 <a:tc>
                   <a:txBody>
                     <a:bodyPr/>
@@ -7412,7 +6939,7 @@
                         </a:lnSpc>
                       </a:pPr>
                       <a:r>
-                        <a:rPr sz="950" b="1">
+                        <a:rPr sz="900" b="1">
                           <a:solidFill>
                             <a:srgbClr val="1A1A1A"/>
                           </a:solidFill>
@@ -7422,7 +6949,7 @@
                       </a:r>
                     </a:p>
                   </a:txBody>
-                  <a:tcPr anchor="ctr" marL="54864" marR="45720" marT="18288" marB="18288">
+                  <a:tcPr anchor="ctr" marL="45720" marR="36576" marT="18288" marB="18288">
                     <a:solidFill>
                       <a:srgbClr val="DDDDDD"/>
                     </a:solidFill>
@@ -7439,7 +6966,7 @@
                         </a:lnSpc>
                       </a:pPr>
                       <a:r>
-                        <a:rPr sz="950" b="1">
+                        <a:rPr sz="900" b="1">
                           <a:solidFill>
                             <a:srgbClr val="1A1A1A"/>
                           </a:solidFill>
@@ -7449,7 +6976,7 @@
                       </a:r>
                     </a:p>
                   </a:txBody>
-                  <a:tcPr anchor="ctr" marL="54864" marR="45720" marT="18288" marB="18288">
+                  <a:tcPr anchor="ctr" marL="45720" marR="36576" marT="18288" marB="18288">
                     <a:solidFill>
                       <a:srgbClr val="DDDDDD"/>
                     </a:solidFill>
@@ -7466,7 +6993,7 @@
                         </a:lnSpc>
                       </a:pPr>
                       <a:r>
-                        <a:rPr sz="950" b="1">
+                        <a:rPr sz="900" b="1">
                           <a:solidFill>
                             <a:srgbClr val="1A1A1A"/>
                           </a:solidFill>
@@ -7476,7 +7003,7 @@
                       </a:r>
                     </a:p>
                   </a:txBody>
-                  <a:tcPr anchor="ctr" marL="54864" marR="45720" marT="18288" marB="18288">
+                  <a:tcPr anchor="ctr" marL="45720" marR="36576" marT="18288" marB="18288">
                     <a:solidFill>
                       <a:srgbClr val="DDDDDD"/>
                     </a:solidFill>
@@ -7493,22 +7020,24 @@
                         </a:lnSpc>
                       </a:pPr>
                       <a:r>
-                        <a:rPr sz="950" b="1">
+                        <a:rPr sz="900" b="1">
                           <a:solidFill>
                             <a:srgbClr val="1A1A1A"/>
                           </a:solidFill>
                           <a:latin typeface="Calibri"/>
                         </a:rPr>
-                        <a:t>Method</a:t>
+                        <a:t>Result</a:t>
                       </a:r>
                     </a:p>
                   </a:txBody>
-                  <a:tcPr anchor="ctr" marL="54864" marR="45720" marT="18288" marB="18288">
+                  <a:tcPr anchor="ctr" marL="45720" marR="36576" marT="18288" marB="18288">
                     <a:solidFill>
                       <a:srgbClr val="DDDDDD"/>
                     </a:solidFill>
                   </a:tcPr>
                 </a:tc>
+              </a:tr>
+              <a:tr h="402336">
                 <a:tc>
                   <a:txBody>
                     <a:bodyPr/>
@@ -7520,36 +7049,7 @@
                         </a:lnSpc>
                       </a:pPr>
                       <a:r>
-                        <a:rPr sz="950" b="1">
-                          <a:solidFill>
-                            <a:srgbClr val="1A1A1A"/>
-                          </a:solidFill>
-                          <a:latin typeface="Calibri"/>
-                        </a:rPr>
-                        <a:t>Result</a:t>
-                      </a:r>
-                    </a:p>
-                  </a:txBody>
-                  <a:tcPr anchor="ctr" marL="54864" marR="45720" marT="18288" marB="18288">
-                    <a:solidFill>
-                      <a:srgbClr val="DDDDDD"/>
-                    </a:solidFill>
-                  </a:tcPr>
-                </a:tc>
-              </a:tr>
-              <a:tr h="420624">
-                <a:tc>
-                  <a:txBody>
-                    <a:bodyPr/>
-                    <a:lstStyle/>
-                    <a:p>
-                      <a:pPr>
-                        <a:lnSpc>
-                          <a:spcPct val="100000"/>
-                        </a:lnSpc>
-                      </a:pPr>
-                      <a:r>
-                        <a:rPr sz="900" b="0">
+                        <a:rPr sz="850" b="0">
                           <a:solidFill>
                             <a:srgbClr val="1A1A1A"/>
                           </a:solidFill>
@@ -7559,7 +7059,7 @@
                       </a:r>
                     </a:p>
                   </a:txBody>
-                  <a:tcPr anchor="ctr" marL="54864" marR="45720" marT="18288" marB="18288">
+                  <a:tcPr anchor="ctr" marL="45720" marR="36576" marT="18288" marB="18288">
                     <a:solidFill>
                       <a:srgbClr val="FFFFFF"/>
                     </a:solidFill>
@@ -7576,7 +7076,7 @@
                         </a:lnSpc>
                       </a:pPr>
                       <a:r>
-                        <a:rPr sz="900" b="0">
+                        <a:rPr sz="850" b="0">
                           <a:solidFill>
                             <a:srgbClr val="1A1A1A"/>
                           </a:solidFill>
@@ -7586,7 +7086,7 @@
                       </a:r>
                     </a:p>
                   </a:txBody>
-                  <a:tcPr anchor="ctr" marL="54864" marR="45720" marT="18288" marB="18288">
+                  <a:tcPr anchor="ctr" marL="45720" marR="36576" marT="18288" marB="18288">
                     <a:solidFill>
                       <a:srgbClr val="FFFFFF"/>
                     </a:solidFill>
@@ -7603,7 +7103,7 @@
                         </a:lnSpc>
                       </a:pPr>
                       <a:r>
-                        <a:rPr sz="900" b="0">
+                        <a:rPr sz="850" b="0">
                           <a:solidFill>
                             <a:srgbClr val="1A1A1A"/>
                           </a:solidFill>
@@ -7613,7 +7113,7 @@
                       </a:r>
                     </a:p>
                   </a:txBody>
-                  <a:tcPr anchor="ctr" marL="54864" marR="45720" marT="18288" marB="18288">
+                  <a:tcPr anchor="ctr" marL="45720" marR="36576" marT="18288" marB="18288">
                     <a:solidFill>
                       <a:srgbClr val="FFFFFF"/>
                     </a:solidFill>
@@ -7630,17 +7130,156 @@
                         </a:lnSpc>
                       </a:pPr>
                       <a:r>
-                        <a:rPr sz="900" b="0">
+                        <a:rPr sz="850" b="0">
                           <a:solidFill>
                             <a:srgbClr val="1A1A1A"/>
                           </a:solidFill>
                           <a:latin typeface="Calibri"/>
                         </a:rPr>
-                        <a:t>ResNet / Swin + FPN</a:t>
+                        <a:t>wF1 69.2 (5 cat.), 59.4 (10 cat.)</a:t>
                       </a:r>
                     </a:p>
                   </a:txBody>
-                  <a:tcPr anchor="ctr" marL="54864" marR="45720" marT="18288" marB="18288">
+                  <a:tcPr anchor="ctr" marL="45720" marR="36576" marT="18288" marB="18288">
+                    <a:solidFill>
+                      <a:srgbClr val="FFFFFF"/>
+                    </a:solidFill>
+                  </a:tcPr>
+                </a:tc>
+              </a:tr>
+              <a:tr h="402336">
+                <a:tc>
+                  <a:txBody>
+                    <a:bodyPr/>
+                    <a:lstStyle/>
+                    <a:p>
+                      <a:pPr>
+                        <a:lnSpc>
+                          <a:spcPct val="100000"/>
+                        </a:lnSpc>
+                      </a:pPr>
+                      <a:r>
+                        <a:rPr sz="850" b="0">
+                          <a:solidFill>
+                            <a:srgbClr val="1A1A1A"/>
+                          </a:solidFill>
+                          <a:latin typeface="Calibri"/>
+                        </a:rPr>
+                        <a:t>Saba 2026</a:t>
+                      </a:r>
+                    </a:p>
+                  </a:txBody>
+                  <a:tcPr anchor="ctr" marL="45720" marR="36576" marT="18288" marB="18288">
+                    <a:solidFill>
+                      <a:srgbClr val="F5F5F5"/>
+                    </a:solidFill>
+                  </a:tcPr>
+                </a:tc>
+                <a:tc>
+                  <a:txBody>
+                    <a:bodyPr/>
+                    <a:lstStyle/>
+                    <a:p>
+                      <a:pPr>
+                        <a:lnSpc>
+                          <a:spcPct val="100000"/>
+                        </a:lnSpc>
+                      </a:pPr>
+                      <a:r>
+                        <a:rPr sz="850" b="0">
+                          <a:solidFill>
+                            <a:srgbClr val="1A1A1A"/>
+                          </a:solidFill>
+                          <a:latin typeface="Calibri"/>
+                        </a:rPr>
+                        <a:t>WV-3 VNIR, 1.24 m</a:t>
+                      </a:r>
+                    </a:p>
+                  </a:txBody>
+                  <a:tcPr anchor="ctr" marL="45720" marR="36576" marT="18288" marB="18288">
+                    <a:solidFill>
+                      <a:srgbClr val="F5F5F5"/>
+                    </a:solidFill>
+                  </a:tcPr>
+                </a:tc>
+                <a:tc>
+                  <a:txBody>
+                    <a:bodyPr/>
+                    <a:lstStyle/>
+                    <a:p>
+                      <a:pPr>
+                        <a:lnSpc>
+                          <a:spcPct val="100000"/>
+                        </a:lnSpc>
+                      </a:pPr>
+                      <a:r>
+                        <a:rPr sz="850" b="0">
+                          <a:solidFill>
+                            <a:srgbClr val="1A1A1A"/>
+                          </a:solidFill>
+                          <a:latin typeface="Calibri"/>
+                        </a:rPr>
+                        <a:t>pixel cls.</a:t>
+                      </a:r>
+                    </a:p>
+                  </a:txBody>
+                  <a:tcPr anchor="ctr" marL="45720" marR="36576" marT="18288" marB="18288">
+                    <a:solidFill>
+                      <a:srgbClr val="F5F5F5"/>
+                    </a:solidFill>
+                  </a:tcPr>
+                </a:tc>
+                <a:tc>
+                  <a:txBody>
+                    <a:bodyPr/>
+                    <a:lstStyle/>
+                    <a:p>
+                      <a:pPr>
+                        <a:lnSpc>
+                          <a:spcPct val="100000"/>
+                        </a:lnSpc>
+                      </a:pPr>
+                      <a:r>
+                        <a:rPr sz="850" b="0">
+                          <a:solidFill>
+                            <a:srgbClr val="1A1A1A"/>
+                          </a:solidFill>
+                          <a:latin typeface="Calibri"/>
+                        </a:rPr>
+                        <a:t>asbestos, Macro-F1 97.6</a:t>
+                      </a:r>
+                    </a:p>
+                  </a:txBody>
+                  <a:tcPr anchor="ctr" marL="45720" marR="36576" marT="18288" marB="18288">
+                    <a:solidFill>
+                      <a:srgbClr val="F5F5F5"/>
+                    </a:solidFill>
+                  </a:tcPr>
+                </a:tc>
+              </a:tr>
+              <a:tr h="402336">
+                <a:tc>
+                  <a:txBody>
+                    <a:bodyPr/>
+                    <a:lstStyle/>
+                    <a:p>
+                      <a:pPr>
+                        <a:lnSpc>
+                          <a:spcPct val="100000"/>
+                        </a:lnSpc>
+                      </a:pPr>
+                      <a:r>
+                        <a:rPr sz="850" b="0">
+                          <a:solidFill>
+                            <a:srgbClr val="1A1A1A"/>
+                          </a:solidFill>
+                          <a:latin typeface="Calibri"/>
+                        </a:rPr>
+                        <a:t>Bonifazi 2026</a:t>
+                      </a:r>
+                    </a:p>
+                  </a:txBody>
+                  <a:tcPr anchor="ctr" marL="45720" marR="36576" marT="18288" marB="18288">
                     <a:solidFill>
                       <a:srgbClr val="FFFFFF"/>
                     </a:solidFill>
@@ -7657,24 +7296,22 @@
                         </a:lnSpc>
                       </a:pPr>
                       <a:r>
-                        <a:rPr sz="900" b="0">
+                        <a:rPr sz="850" b="0">
                           <a:solidFill>
                             <a:srgbClr val="1A1A1A"/>
                           </a:solidFill>
                           <a:latin typeface="Calibri"/>
                         </a:rPr>
-                        <a:t>wF1 69.2 (5 cat.), 59.4 (10 cat.)</a:t>
+                        <a:t>WV-3 VNIR+SWIR</a:t>
                       </a:r>
                     </a:p>
                   </a:txBody>
-                  <a:tcPr anchor="ctr" marL="54864" marR="45720" marT="18288" marB="18288">
+                  <a:tcPr anchor="ctr" marL="45720" marR="36576" marT="18288" marB="18288">
                     <a:solidFill>
                       <a:srgbClr val="FFFFFF"/>
                     </a:solidFill>
                   </a:tcPr>
                 </a:tc>
-              </a:tr>
-              <a:tr h="420624">
                 <a:tc>
                   <a:txBody>
                     <a:bodyPr/>
@@ -7686,17 +7323,73 @@
                         </a:lnSpc>
                       </a:pPr>
                       <a:r>
-                        <a:rPr sz="900" b="0">
+                        <a:rPr sz="850" b="0">
                           <a:solidFill>
                             <a:srgbClr val="1A1A1A"/>
                           </a:solidFill>
                           <a:latin typeface="Calibri"/>
                         </a:rPr>
-                        <a:t>Saba 2026</a:t>
+                        <a:t>pixel cls.</a:t>
                       </a:r>
                     </a:p>
                   </a:txBody>
-                  <a:tcPr anchor="ctr" marL="54864" marR="45720" marT="18288" marB="18288">
+                  <a:tcPr anchor="ctr" marL="45720" marR="36576" marT="18288" marB="18288">
+                    <a:solidFill>
+                      <a:srgbClr val="FFFFFF"/>
+                    </a:solidFill>
+                  </a:tcPr>
+                </a:tc>
+                <a:tc>
+                  <a:txBody>
+                    <a:bodyPr/>
+                    <a:lstStyle/>
+                    <a:p>
+                      <a:pPr>
+                        <a:lnSpc>
+                          <a:spcPct val="100000"/>
+                        </a:lnSpc>
+                      </a:pPr>
+                      <a:r>
+                        <a:rPr sz="850" b="0">
+                          <a:solidFill>
+                            <a:srgbClr val="1A1A1A"/>
+                          </a:solidFill>
+                          <a:latin typeface="Calibri"/>
+                        </a:rPr>
+                        <a:t>asbestos roofs, removal tracking</a:t>
+                      </a:r>
+                    </a:p>
+                  </a:txBody>
+                  <a:tcPr anchor="ctr" marL="45720" marR="36576" marT="18288" marB="18288">
+                    <a:solidFill>
+                      <a:srgbClr val="FFFFFF"/>
+                    </a:solidFill>
+                  </a:tcPr>
+                </a:tc>
+              </a:tr>
+              <a:tr h="402336">
+                <a:tc>
+                  <a:txBody>
+                    <a:bodyPr/>
+                    <a:lstStyle/>
+                    <a:p>
+                      <a:pPr>
+                        <a:lnSpc>
+                          <a:spcPct val="100000"/>
+                        </a:lnSpc>
+                      </a:pPr>
+                      <a:r>
+                        <a:rPr sz="850" b="0">
+                          <a:solidFill>
+                            <a:srgbClr val="1A1A1A"/>
+                          </a:solidFill>
+                          <a:latin typeface="Calibri"/>
+                        </a:rPr>
+                        <a:t>Abbasi 2024</a:t>
+                      </a:r>
+                    </a:p>
+                  </a:txBody>
+                  <a:tcPr anchor="ctr" marL="45720" marR="36576" marT="18288" marB="18288">
                     <a:solidFill>
                       <a:srgbClr val="F5F5F5"/>
                     </a:solidFill>
@@ -7713,17 +7406,17 @@
                         </a:lnSpc>
                       </a:pPr>
                       <a:r>
-                        <a:rPr sz="900" b="0">
+                        <a:rPr sz="850" b="0">
                           <a:solidFill>
                             <a:srgbClr val="1A1A1A"/>
                           </a:solidFill>
                           <a:latin typeface="Calibri"/>
                         </a:rPr>
-                        <a:t>WV-3 VNIR, 1.24 m</a:t>
+                        <a:t>aerial RGB</a:t>
                       </a:r>
                     </a:p>
                   </a:txBody>
-                  <a:tcPr anchor="ctr" marL="54864" marR="45720" marT="18288" marB="18288">
+                  <a:tcPr anchor="ctr" marL="45720" marR="36576" marT="18288" marB="18288">
                     <a:solidFill>
                       <a:srgbClr val="F5F5F5"/>
                     </a:solidFill>
@@ -7740,17 +7433,17 @@
                         </a:lnSpc>
                       </a:pPr>
                       <a:r>
-                        <a:rPr sz="900" b="0">
+                        <a:rPr sz="850" b="0">
                           <a:solidFill>
                             <a:srgbClr val="1A1A1A"/>
                           </a:solidFill>
                           <a:latin typeface="Calibri"/>
                         </a:rPr>
-                        <a:t>pixel cls.</a:t>
+                        <a:t>OBIA cls.</a:t>
                       </a:r>
                     </a:p>
                   </a:txBody>
-                  <a:tcPr anchor="ctr" marL="54864" marR="45720" marT="18288" marB="18288">
+                  <a:tcPr anchor="ctr" marL="45720" marR="36576" marT="18288" marB="18288">
                     <a:solidFill>
                       <a:srgbClr val="F5F5F5"/>
                     </a:solidFill>
@@ -7767,22 +7460,24 @@
                         </a:lnSpc>
                       </a:pPr>
                       <a:r>
-                        <a:rPr sz="900" b="0">
+                        <a:rPr sz="850" b="0">
                           <a:solidFill>
                             <a:srgbClr val="1A1A1A"/>
                           </a:solidFill>
                           <a:latin typeface="Calibri"/>
                         </a:rPr>
-                        <a:t>Fine-KNN (32 tested)</a:t>
+                        <a:t>asbestos, OA ~96 (shape + time)</a:t>
                       </a:r>
                     </a:p>
                   </a:txBody>
-                  <a:tcPr anchor="ctr" marL="54864" marR="45720" marT="18288" marB="18288">
+                  <a:tcPr anchor="ctr" marL="45720" marR="36576" marT="18288" marB="18288">
                     <a:solidFill>
                       <a:srgbClr val="F5F5F5"/>
                     </a:solidFill>
                   </a:tcPr>
                 </a:tc>
+              </a:tr>
+              <a:tr h="402336">
                 <a:tc>
                   <a:txBody>
                     <a:bodyPr/>
@@ -7794,46 +7489,17 @@
                         </a:lnSpc>
                       </a:pPr>
                       <a:r>
-                        <a:rPr sz="900" b="0">
+                        <a:rPr sz="850" b="0">
                           <a:solidFill>
                             <a:srgbClr val="1A1A1A"/>
                           </a:solidFill>
                           <a:latin typeface="Calibri"/>
                         </a:rPr>
-                        <a:t>asbestos, Macro-F1 97.6</a:t>
+                        <a:t>Cilia 2015</a:t>
                       </a:r>
                     </a:p>
                   </a:txBody>
-                  <a:tcPr anchor="ctr" marL="54864" marR="45720" marT="18288" marB="18288">
-                    <a:solidFill>
-                      <a:srgbClr val="F5F5F5"/>
-                    </a:solidFill>
-                  </a:tcPr>
-                </a:tc>
-              </a:tr>
-              <a:tr h="420624">
-                <a:tc>
-                  <a:txBody>
-                    <a:bodyPr/>
-                    <a:lstStyle/>
-                    <a:p>
-                      <a:pPr>
-                        <a:lnSpc>
-                          <a:spcPct val="100000"/>
-                        </a:lnSpc>
-                      </a:pPr>
-                      <a:r>
-                        <a:rPr sz="900" b="0">
-                          <a:solidFill>
-                            <a:srgbClr val="1A1A1A"/>
-                          </a:solidFill>
-                          <a:latin typeface="Calibri"/>
-                        </a:rPr>
-                        <a:t>Bonifazi 2026</a:t>
-                      </a:r>
-                    </a:p>
-                  </a:txBody>
-                  <a:tcPr anchor="ctr" marL="54864" marR="45720" marT="18288" marB="18288">
+                  <a:tcPr anchor="ctr" marL="45720" marR="36576" marT="18288" marB="18288">
                     <a:solidFill>
                       <a:srgbClr val="FFFFFF"/>
                     </a:solidFill>
@@ -7850,17 +7516,17 @@
                         </a:lnSpc>
                       </a:pPr>
                       <a:r>
-                        <a:rPr sz="900" b="0">
+                        <a:rPr sz="850" b="0">
                           <a:solidFill>
                             <a:srgbClr val="1A1A1A"/>
                           </a:solidFill>
                           <a:latin typeface="Calibri"/>
                         </a:rPr>
-                        <a:t>WV-3 VNIR+SWIR, 1.24/3.7 m</a:t>
+                        <a:t>airborne HSI, 3 m</a:t>
                       </a:r>
                     </a:p>
                   </a:txBody>
-                  <a:tcPr anchor="ctr" marL="54864" marR="45720" marT="18288" marB="18288">
+                  <a:tcPr anchor="ctr" marL="45720" marR="36576" marT="18288" marB="18288">
                     <a:solidFill>
                       <a:srgbClr val="FFFFFF"/>
                     </a:solidFill>
@@ -7877,7 +7543,7 @@
                         </a:lnSpc>
                       </a:pPr>
                       <a:r>
-                        <a:rPr sz="900" b="0">
+                        <a:rPr sz="850" b="0">
                           <a:solidFill>
                             <a:srgbClr val="1A1A1A"/>
                           </a:solidFill>
@@ -7887,7 +7553,7 @@
                       </a:r>
                     </a:p>
                   </a:txBody>
-                  <a:tcPr anchor="ctr" marL="54864" marR="45720" marT="18288" marB="18288">
+                  <a:tcPr anchor="ctr" marL="45720" marR="36576" marT="18288" marB="18288">
                     <a:solidFill>
                       <a:srgbClr val="FFFFFF"/>
                     </a:solidFill>
@@ -7904,308 +7570,7 @@
                         </a:lnSpc>
                       </a:pPr>
                       <a:r>
-                        <a:rPr sz="900" b="0">
-                          <a:solidFill>
-                            <a:srgbClr val="1A1A1A"/>
-                          </a:solidFill>
-                          <a:latin typeface="Calibri"/>
-                        </a:rPr>
-                        <a:t>max likelihood, temporal</a:t>
-                      </a:r>
-                    </a:p>
-                  </a:txBody>
-                  <a:tcPr anchor="ctr" marL="54864" marR="45720" marT="18288" marB="18288">
-                    <a:solidFill>
-                      <a:srgbClr val="FFFFFF"/>
-                    </a:solidFill>
-                  </a:tcPr>
-                </a:tc>
-                <a:tc>
-                  <a:txBody>
-                    <a:bodyPr/>
-                    <a:lstStyle/>
-                    <a:p>
-                      <a:pPr>
-                        <a:lnSpc>
-                          <a:spcPct val="100000"/>
-                        </a:lnSpc>
-                      </a:pPr>
-                      <a:r>
-                        <a:rPr sz="900" b="0">
-                          <a:solidFill>
-                            <a:srgbClr val="1A1A1A"/>
-                          </a:solidFill>
-                          <a:latin typeface="Calibri"/>
-                        </a:rPr>
-                        <a:t>asbestos roofs, removal tracking</a:t>
-                      </a:r>
-                    </a:p>
-                  </a:txBody>
-                  <a:tcPr anchor="ctr" marL="54864" marR="45720" marT="18288" marB="18288">
-                    <a:solidFill>
-                      <a:srgbClr val="FFFFFF"/>
-                    </a:solidFill>
-                  </a:tcPr>
-                </a:tc>
-              </a:tr>
-              <a:tr h="420624">
-                <a:tc>
-                  <a:txBody>
-                    <a:bodyPr/>
-                    <a:lstStyle/>
-                    <a:p>
-                      <a:pPr>
-                        <a:lnSpc>
-                          <a:spcPct val="100000"/>
-                        </a:lnSpc>
-                      </a:pPr>
-                      <a:r>
-                        <a:rPr sz="900" b="0">
-                          <a:solidFill>
-                            <a:srgbClr val="1A1A1A"/>
-                          </a:solidFill>
-                          <a:latin typeface="Calibri"/>
-                        </a:rPr>
-                        <a:t>Abbasi 2024</a:t>
-                      </a:r>
-                    </a:p>
-                  </a:txBody>
-                  <a:tcPr anchor="ctr" marL="54864" marR="45720" marT="18288" marB="18288">
-                    <a:solidFill>
-                      <a:srgbClr val="F5F5F5"/>
-                    </a:solidFill>
-                  </a:tcPr>
-                </a:tc>
-                <a:tc>
-                  <a:txBody>
-                    <a:bodyPr/>
-                    <a:lstStyle/>
-                    <a:p>
-                      <a:pPr>
-                        <a:lnSpc>
-                          <a:spcPct val="100000"/>
-                        </a:lnSpc>
-                      </a:pPr>
-                      <a:r>
-                        <a:rPr sz="900" b="0">
-                          <a:solidFill>
-                            <a:srgbClr val="1A1A1A"/>
-                          </a:solidFill>
-                          <a:latin typeface="Calibri"/>
-                        </a:rPr>
-                        <a:t>aerial RGB</a:t>
-                      </a:r>
-                    </a:p>
-                  </a:txBody>
-                  <a:tcPr anchor="ctr" marL="54864" marR="45720" marT="18288" marB="18288">
-                    <a:solidFill>
-                      <a:srgbClr val="F5F5F5"/>
-                    </a:solidFill>
-                  </a:tcPr>
-                </a:tc>
-                <a:tc>
-                  <a:txBody>
-                    <a:bodyPr/>
-                    <a:lstStyle/>
-                    <a:p>
-                      <a:pPr>
-                        <a:lnSpc>
-                          <a:spcPct val="100000"/>
-                        </a:lnSpc>
-                      </a:pPr>
-                      <a:r>
-                        <a:rPr sz="900" b="0">
-                          <a:solidFill>
-                            <a:srgbClr val="1A1A1A"/>
-                          </a:solidFill>
-                          <a:latin typeface="Calibri"/>
-                        </a:rPr>
-                        <a:t>OBIA cls.</a:t>
-                      </a:r>
-                    </a:p>
-                  </a:txBody>
-                  <a:tcPr anchor="ctr" marL="54864" marR="45720" marT="18288" marB="18288">
-                    <a:solidFill>
-                      <a:srgbClr val="F5F5F5"/>
-                    </a:solidFill>
-                  </a:tcPr>
-                </a:tc>
-                <a:tc>
-                  <a:txBody>
-                    <a:bodyPr/>
-                    <a:lstStyle/>
-                    <a:p>
-                      <a:pPr>
-                        <a:lnSpc>
-                          <a:spcPct val="100000"/>
-                        </a:lnSpc>
-                      </a:pPr>
-                      <a:r>
-                        <a:rPr sz="900" b="0">
-                          <a:solidFill>
-                            <a:srgbClr val="1A1A1A"/>
-                          </a:solidFill>
-                          <a:latin typeface="Calibri"/>
-                        </a:rPr>
-                        <a:t>DenseNet + LSTM</a:t>
-                      </a:r>
-                    </a:p>
-                  </a:txBody>
-                  <a:tcPr anchor="ctr" marL="54864" marR="45720" marT="18288" marB="18288">
-                    <a:solidFill>
-                      <a:srgbClr val="F5F5F5"/>
-                    </a:solidFill>
-                  </a:tcPr>
-                </a:tc>
-                <a:tc>
-                  <a:txBody>
-                    <a:bodyPr/>
-                    <a:lstStyle/>
-                    <a:p>
-                      <a:pPr>
-                        <a:lnSpc>
-                          <a:spcPct val="100000"/>
-                        </a:lnSpc>
-                      </a:pPr>
-                      <a:r>
-                        <a:rPr sz="900" b="0">
-                          <a:solidFill>
-                            <a:srgbClr val="1A1A1A"/>
-                          </a:solidFill>
-                          <a:latin typeface="Calibri"/>
-                        </a:rPr>
-                        <a:t>asbestos, OA ~96 (shape + time)</a:t>
-                      </a:r>
-                    </a:p>
-                  </a:txBody>
-                  <a:tcPr anchor="ctr" marL="54864" marR="45720" marT="18288" marB="18288">
-                    <a:solidFill>
-                      <a:srgbClr val="F5F5F5"/>
-                    </a:solidFill>
-                  </a:tcPr>
-                </a:tc>
-              </a:tr>
-              <a:tr h="420624">
-                <a:tc>
-                  <a:txBody>
-                    <a:bodyPr/>
-                    <a:lstStyle/>
-                    <a:p>
-                      <a:pPr>
-                        <a:lnSpc>
-                          <a:spcPct val="100000"/>
-                        </a:lnSpc>
-                      </a:pPr>
-                      <a:r>
-                        <a:rPr sz="900" b="0">
-                          <a:solidFill>
-                            <a:srgbClr val="1A1A1A"/>
-                          </a:solidFill>
-                          <a:latin typeface="Calibri"/>
-                        </a:rPr>
-                        <a:t>Cilia 2015</a:t>
-                      </a:r>
-                    </a:p>
-                  </a:txBody>
-                  <a:tcPr anchor="ctr" marL="54864" marR="45720" marT="18288" marB="18288">
-                    <a:solidFill>
-                      <a:srgbClr val="FFFFFF"/>
-                    </a:solidFill>
-                  </a:tcPr>
-                </a:tc>
-                <a:tc>
-                  <a:txBody>
-                    <a:bodyPr/>
-                    <a:lstStyle/>
-                    <a:p>
-                      <a:pPr>
-                        <a:lnSpc>
-                          <a:spcPct val="100000"/>
-                        </a:lnSpc>
-                      </a:pPr>
-                      <a:r>
-                        <a:rPr sz="900" b="0">
-                          <a:solidFill>
-                            <a:srgbClr val="1A1A1A"/>
-                          </a:solidFill>
-                          <a:latin typeface="Calibri"/>
-                        </a:rPr>
-                        <a:t>airborne HSI, 3 m</a:t>
-                      </a:r>
-                    </a:p>
-                  </a:txBody>
-                  <a:tcPr anchor="ctr" marL="54864" marR="45720" marT="18288" marB="18288">
-                    <a:solidFill>
-                      <a:srgbClr val="FFFFFF"/>
-                    </a:solidFill>
-                  </a:tcPr>
-                </a:tc>
-                <a:tc>
-                  <a:txBody>
-                    <a:bodyPr/>
-                    <a:lstStyle/>
-                    <a:p>
-                      <a:pPr>
-                        <a:lnSpc>
-                          <a:spcPct val="100000"/>
-                        </a:lnSpc>
-                      </a:pPr>
-                      <a:r>
-                        <a:rPr sz="900" b="0">
-                          <a:solidFill>
-                            <a:srgbClr val="1A1A1A"/>
-                          </a:solidFill>
-                          <a:latin typeface="Calibri"/>
-                        </a:rPr>
-                        <a:t>pixel cls.</a:t>
-                      </a:r>
-                    </a:p>
-                  </a:txBody>
-                  <a:tcPr anchor="ctr" marL="54864" marR="45720" marT="18288" marB="18288">
-                    <a:solidFill>
-                      <a:srgbClr val="FFFFFF"/>
-                    </a:solidFill>
-                  </a:tcPr>
-                </a:tc>
-                <a:tc>
-                  <a:txBody>
-                    <a:bodyPr/>
-                    <a:lstStyle/>
-                    <a:p>
-                      <a:pPr>
-                        <a:lnSpc>
-                          <a:spcPct val="100000"/>
-                        </a:lnSpc>
-                      </a:pPr>
-                      <a:r>
-                        <a:rPr sz="900" b="0">
-                          <a:solidFill>
-                            <a:srgbClr val="1A1A1A"/>
-                          </a:solidFill>
-                          <a:latin typeface="Calibri"/>
-                        </a:rPr>
-                        <a:t>SAM + weathering index</a:t>
-                      </a:r>
-                    </a:p>
-                  </a:txBody>
-                  <a:tcPr anchor="ctr" marL="54864" marR="45720" marT="18288" marB="18288">
-                    <a:solidFill>
-                      <a:srgbClr val="FFFFFF"/>
-                    </a:solidFill>
-                  </a:tcPr>
-                </a:tc>
-                <a:tc>
-                  <a:txBody>
-                    <a:bodyPr/>
-                    <a:lstStyle/>
-                    <a:p>
-                      <a:pPr>
-                        <a:lnSpc>
-                          <a:spcPct val="100000"/>
-                        </a:lnSpc>
-                      </a:pPr>
-                      <a:r>
-                        <a:rPr sz="900" b="0">
+                        <a:rPr sz="850" b="0">
                           <a:solidFill>
                             <a:srgbClr val="1A1A1A"/>
                           </a:solidFill>
@@ -8215,7 +7580,7 @@
                       </a:r>
                     </a:p>
                   </a:txBody>
-                  <a:tcPr anchor="ctr" marL="54864" marR="45720" marT="18288" marB="18288">
+                  <a:tcPr anchor="ctr" marL="45720" marR="36576" marT="18288" marB="18288">
                     <a:solidFill>
                       <a:srgbClr val="FFFFFF"/>
                     </a:solidFill>
@@ -8226,15 +7591,81 @@
           </a:graphicData>
         </a:graphic>
       </p:graphicFrame>
-      <p:sp>
-        <p:nvSpPr>
-          <p:cNvPr id="4" name="TextBox 3"/>
+      <p:pic>
+        <p:nvPicPr>
+          <p:cNvPr id="4" name="Picture 3" descr="bonifazi_example.png"/>
+          <p:cNvPicPr>
+            <a:picLocks noChangeAspect="1"/>
+          </p:cNvPicPr>
+          <p:nvPr/>
+        </p:nvPicPr>
+        <p:blipFill>
+          <a:blip r:embed="rId2"/>
+          <a:stretch>
+            <a:fillRect/>
+          </a:stretch>
+        </p:blipFill>
+        <p:spPr>
+          <a:xfrm>
+            <a:off x="6400800" y="1580875"/>
+            <a:ext cx="2331720" cy="2187489"/>
+          </a:xfrm>
+          <a:prstGeom prst="rect">
+            <a:avLst/>
+          </a:prstGeom>
+        </p:spPr>
+      </p:pic>
+      <p:sp>
+        <p:nvSpPr>
+          <p:cNvPr id="5" name="TextBox 4"/>
           <p:cNvSpPr txBox="1"/>
           <p:nvPr/>
         </p:nvSpPr>
         <p:spPr>
           <a:xfrm>
-            <a:off x="411480" y="4791456"/>
+            <a:off x="411480" y="3703320"/>
+            <a:ext cx="5806440" cy="914400"/>
+          </a:xfrm>
+          <a:prstGeom prst="rect">
+            <a:avLst/>
+          </a:prstGeom>
+          <a:noFill/>
+        </p:spPr>
+        <p:txBody>
+          <a:bodyPr wrap="square">
+            <a:spAutoFit/>
+          </a:bodyPr>
+          <a:lstStyle/>
+          <a:p>
+            <a:pPr algn="l">
+              <a:lnSpc>
+                <a:spcPct val="112000"/>
+              </a:lnSpc>
+              <a:spcAft>
+                <a:spcPts val="600"/>
+              </a:spcAft>
+            </a:pPr>
+            <a:r>
+              <a:rPr sz="1050" b="0" i="0">
+                <a:solidFill>
+                  <a:srgbClr val="666666"/>
+                </a:solidFill>
+                <a:latin typeface="Calibri"/>
+              </a:rPr>
+              <a:t>One multi-material predecessor (Alari). The rest is asbestos only. Right: building-level asbestos classification on WorldView-3 (Bonifazi 2026).</a:t>
+            </a:r>
+          </a:p>
+        </p:txBody>
+      </p:sp>
+      <p:sp>
+        <p:nvSpPr>
+          <p:cNvPr id="6" name="TextBox 5"/>
+          <p:cNvSpPr txBox="1"/>
+          <p:nvPr/>
+        </p:nvSpPr>
+        <p:spPr>
+          <a:xfrm>
+            <a:off x="411480" y="4809744"/>
             <a:ext cx="8321040" cy="237744"/>
           </a:xfrm>
           <a:prstGeom prst="rect">
@@ -8250,7 +7681,7 @@
           <a:p>
             <a:pPr algn="l">
               <a:lnSpc>
-                <a:spcPct val="115000"/>
+                <a:spcPct val="112000"/>
               </a:lnSpc>
               <a:spcAft>
                 <a:spcPts val="0"/>
@@ -8263,20 +7694,20 @@
                 </a:solidFill>
                 <a:latin typeface="Calibri"/>
               </a:rPr>
-              <a:t>One multi-material predecessor (Alari, group thesis). The rest is asbestos only. Saba and Abbasi: paywalled or preprint.</a:t>
-            </a:r>
-          </a:p>
-        </p:txBody>
-      </p:sp>
-      <p:sp>
-        <p:nvSpPr>
-          <p:cNvPr id="5" name="TextBox 4"/>
+              <a:t>Saba and Abbasi: paywalled or preprint  ·  image: Bonifazi et al. 2026, Geomatics (CC BY 4.0)</a:t>
+            </a:r>
+          </a:p>
+        </p:txBody>
+      </p:sp>
+      <p:sp>
+        <p:nvSpPr>
+          <p:cNvPr id="7" name="TextBox 6"/>
           <p:cNvSpPr txBox="1"/>
           <p:nvPr/>
         </p:nvSpPr>
         <p:spPr>
           <a:xfrm>
-            <a:off x="91440" y="4791456"/>
+            <a:off x="91440" y="4809744"/>
             <a:ext cx="411480" cy="256032"/>
           </a:xfrm>
           <a:prstGeom prst="rect">
@@ -8329,8 +7760,8 @@
         </p:nvSpPr>
         <p:spPr>
           <a:xfrm>
-            <a:off x="411480" y="274320"/>
-            <a:ext cx="8321040" cy="594360"/>
+            <a:off x="411480" y="256032"/>
+            <a:ext cx="8321040" cy="548640"/>
           </a:xfrm>
           <a:prstGeom prst="rect">
             <a:avLst/>
@@ -8345,7 +7776,7 @@
           <a:p>
             <a:pPr algn="l">
               <a:lnSpc>
-                <a:spcPct val="115000"/>
+                <a:spcPct val="112000"/>
               </a:lnSpc>
               <a:spcAft>
                 <a:spcPts val="600"/>
@@ -8387,14 +7818,14 @@
           <a:p>
             <a:pPr algn="l">
               <a:lnSpc>
-                <a:spcPct val="115000"/>
+                <a:spcPct val="112000"/>
               </a:lnSpc>
               <a:spcAft>
                 <a:spcPts val="600"/>
               </a:spcAft>
             </a:pPr>
             <a:r>
-              <a:rPr sz="1250" b="0" i="0">
+              <a:rPr sz="1200" b="0" i="0">
                 <a:solidFill>
                   <a:srgbClr val="1A1A1A"/>
                 </a:solidFill>
@@ -8406,14 +7837,14 @@
           <a:p>
             <a:pPr algn="l">
               <a:lnSpc>
-                <a:spcPct val="115000"/>
+                <a:spcPct val="112000"/>
               </a:lnSpc>
               <a:spcAft>
                 <a:spcPts val="600"/>
               </a:spcAft>
             </a:pPr>
             <a:r>
-              <a:rPr sz="1250" b="0" i="0">
+              <a:rPr sz="1200" b="0" i="0">
                 <a:solidFill>
                   <a:srgbClr val="1A1A1A"/>
                 </a:solidFill>
@@ -8425,14 +7856,14 @@
           <a:p>
             <a:pPr algn="l">
               <a:lnSpc>
-                <a:spcPct val="115000"/>
+                <a:spcPct val="112000"/>
               </a:lnSpc>
               <a:spcAft>
                 <a:spcPts val="600"/>
               </a:spcAft>
             </a:pPr>
             <a:r>
-              <a:rPr sz="1250" b="0" i="0">
+              <a:rPr sz="1200" b="0" i="0">
                 <a:solidFill>
                   <a:srgbClr val="1A1A1A"/>
                 </a:solidFill>
@@ -8444,14 +7875,14 @@
           <a:p>
             <a:pPr algn="l">
               <a:lnSpc>
-                <a:spcPct val="115000"/>
+                <a:spcPct val="112000"/>
               </a:lnSpc>
               <a:spcAft>
                 <a:spcPts val="600"/>
               </a:spcAft>
             </a:pPr>
             <a:r>
-              <a:rPr sz="1250" b="0" i="0">
+              <a:rPr sz="1200" b="0" i="0">
                 <a:solidFill>
                   <a:srgbClr val="1A1A1A"/>
                 </a:solidFill>
@@ -8494,7 +7925,7 @@
         </p:nvSpPr>
         <p:spPr>
           <a:xfrm>
-            <a:off x="411480" y="4791456"/>
+            <a:off x="411480" y="4809744"/>
             <a:ext cx="8321040" cy="237744"/>
           </a:xfrm>
           <a:prstGeom prst="rect">
@@ -8510,7 +7941,7 @@
           <a:p>
             <a:pPr algn="l">
               <a:lnSpc>
-                <a:spcPct val="115000"/>
+                <a:spcPct val="112000"/>
               </a:lnSpc>
               <a:spcAft>
                 <a:spcPts val="0"/>
@@ -8536,7 +7967,7 @@
         </p:nvSpPr>
         <p:spPr>
           <a:xfrm>
-            <a:off x="91440" y="4791456"/>
+            <a:off x="91440" y="4809744"/>
             <a:ext cx="411480" cy="256032"/>
           </a:xfrm>
           <a:prstGeom prst="rect">
@@ -8589,8 +8020,8 @@
         </p:nvSpPr>
         <p:spPr>
           <a:xfrm>
-            <a:off x="411480" y="274320"/>
-            <a:ext cx="8321040" cy="594360"/>
+            <a:off x="411480" y="256032"/>
+            <a:ext cx="8321040" cy="548640"/>
           </a:xfrm>
           <a:prstGeom prst="rect">
             <a:avLst/>
@@ -8605,7 +8036,7 @@
           <a:p>
             <a:pPr algn="l">
               <a:lnSpc>
-                <a:spcPct val="115000"/>
+                <a:spcPct val="112000"/>
               </a:lnSpc>
               <a:spcAft>
                 <a:spcPts val="600"/>
@@ -8623,439 +8054,30 @@
           </a:p>
         </p:txBody>
       </p:sp>
-      <p:graphicFrame>
-        <p:nvGraphicFramePr>
-          <p:cNvPr id="3" name="Table 2"/>
-          <p:cNvGraphicFramePr>
-            <a:graphicFrameLocks noGrp="1"/>
-          </p:cNvGraphicFramePr>
+      <p:pic>
+        <p:nvPicPr>
+          <p:cNvPr id="3" name="Picture 2" descr="bands_chart.png"/>
+          <p:cNvPicPr>
+            <a:picLocks noChangeAspect="1"/>
+          </p:cNvPicPr>
           <p:nvPr/>
-        </p:nvGraphicFramePr>
-        <p:xfrm>
-          <a:off x="411480" y="1769364"/>
-          <a:ext cx="8321040" cy="2176272"/>
-        </p:xfrm>
-        <a:graphic>
-          <a:graphicData uri="http://schemas.openxmlformats.org/drawingml/2006/table">
-            <a:tbl>
-              <a:tblPr firstRow="1" bandRow="1">
-                <a:tableStyleId>{5C22544A-7EE6-4342-B048-85BDC9FD1C3A}</a:tableStyleId>
-              </a:tblPr>
-              <a:tblGrid>
-                <a:gridCol w="2377440"/>
-                <a:gridCol w="2971800"/>
-                <a:gridCol w="2971800"/>
-              </a:tblGrid>
-              <a:tr h="347472">
-                <a:tc>
-                  <a:txBody>
-                    <a:bodyPr/>
-                    <a:lstStyle/>
-                    <a:p>
-                      <a:pPr>
-                        <a:lnSpc>
-                          <a:spcPct val="100000"/>
-                        </a:lnSpc>
-                      </a:pPr>
-                    </a:p>
-                  </a:txBody>
-                  <a:tcPr anchor="ctr" marL="54864" marR="45720" marT="18288" marB="18288">
-                    <a:solidFill>
-                      <a:srgbClr val="DDDDDD"/>
-                    </a:solidFill>
-                  </a:tcPr>
-                </a:tc>
-                <a:tc>
-                  <a:txBody>
-                    <a:bodyPr/>
-                    <a:lstStyle/>
-                    <a:p>
-                      <a:pPr>
-                        <a:lnSpc>
-                          <a:spcPct val="100000"/>
-                        </a:lnSpc>
-                      </a:pPr>
-                      <a:r>
-                        <a:rPr sz="1100" b="1">
-                          <a:solidFill>
-                            <a:srgbClr val="1A1A1A"/>
-                          </a:solidFill>
-                          <a:latin typeface="Calibri"/>
-                        </a:rPr>
-                        <a:t>WorldView-3</a:t>
-                      </a:r>
-                    </a:p>
-                  </a:txBody>
-                  <a:tcPr anchor="ctr" marL="54864" marR="45720" marT="18288" marB="18288">
-                    <a:solidFill>
-                      <a:srgbClr val="DDDDDD"/>
-                    </a:solidFill>
-                  </a:tcPr>
-                </a:tc>
-                <a:tc>
-                  <a:txBody>
-                    <a:bodyPr/>
-                    <a:lstStyle/>
-                    <a:p>
-                      <a:pPr>
-                        <a:lnSpc>
-                          <a:spcPct val="100000"/>
-                        </a:lnSpc>
-                      </a:pPr>
-                      <a:r>
-                        <a:rPr sz="1100" b="1">
-                          <a:solidFill>
-                            <a:srgbClr val="1A1A1A"/>
-                          </a:solidFill>
-                          <a:latin typeface="Calibri"/>
-                        </a:rPr>
-                        <a:t>Pléiades Neo</a:t>
-                      </a:r>
-                    </a:p>
-                  </a:txBody>
-                  <a:tcPr anchor="ctr" marL="54864" marR="45720" marT="18288" marB="18288">
-                    <a:solidFill>
-                      <a:srgbClr val="DDDDDD"/>
-                    </a:solidFill>
-                  </a:tcPr>
-                </a:tc>
-              </a:tr>
-              <a:tr h="457200">
-                <a:tc>
-                  <a:txBody>
-                    <a:bodyPr/>
-                    <a:lstStyle/>
-                    <a:p>
-                      <a:pPr>
-                        <a:lnSpc>
-                          <a:spcPct val="100000"/>
-                        </a:lnSpc>
-                      </a:pPr>
-                      <a:r>
-                        <a:rPr sz="1050" b="0">
-                          <a:solidFill>
-                            <a:srgbClr val="1A1A1A"/>
-                          </a:solidFill>
-                          <a:latin typeface="Calibri"/>
-                        </a:rPr>
-                        <a:t>Multispectral</a:t>
-                      </a:r>
-                    </a:p>
-                  </a:txBody>
-                  <a:tcPr anchor="ctr" marL="54864" marR="45720" marT="18288" marB="18288">
-                    <a:solidFill>
-                      <a:srgbClr val="FFFFFF"/>
-                    </a:solidFill>
-                  </a:tcPr>
-                </a:tc>
-                <a:tc>
-                  <a:txBody>
-                    <a:bodyPr/>
-                    <a:lstStyle/>
-                    <a:p>
-                      <a:pPr>
-                        <a:lnSpc>
-                          <a:spcPct val="100000"/>
-                        </a:lnSpc>
-                      </a:pPr>
-                      <a:r>
-                        <a:rPr sz="1050" b="0">
-                          <a:solidFill>
-                            <a:srgbClr val="1A1A1A"/>
-                          </a:solidFill>
-                          <a:latin typeface="Calibri"/>
-                        </a:rPr>
-                        <a:t>8 VNIR bands, 1.24 m</a:t>
-                      </a:r>
-                    </a:p>
-                  </a:txBody>
-                  <a:tcPr anchor="ctr" marL="54864" marR="45720" marT="18288" marB="18288">
-                    <a:solidFill>
-                      <a:srgbClr val="FFFFFF"/>
-                    </a:solidFill>
-                  </a:tcPr>
-                </a:tc>
-                <a:tc>
-                  <a:txBody>
-                    <a:bodyPr/>
-                    <a:lstStyle/>
-                    <a:p>
-                      <a:pPr>
-                        <a:lnSpc>
-                          <a:spcPct val="100000"/>
-                        </a:lnSpc>
-                      </a:pPr>
-                      <a:r>
-                        <a:rPr sz="1050" b="0">
-                          <a:solidFill>
-                            <a:srgbClr val="1A1A1A"/>
-                          </a:solidFill>
-                          <a:latin typeface="Calibri"/>
-                        </a:rPr>
-                        <a:t>6 VNIR bands, 1.2 m</a:t>
-                      </a:r>
-                    </a:p>
-                  </a:txBody>
-                  <a:tcPr anchor="ctr" marL="54864" marR="45720" marT="18288" marB="18288">
-                    <a:solidFill>
-                      <a:srgbClr val="FFFFFF"/>
-                    </a:solidFill>
-                  </a:tcPr>
-                </a:tc>
-              </a:tr>
-              <a:tr h="457200">
-                <a:tc>
-                  <a:txBody>
-                    <a:bodyPr/>
-                    <a:lstStyle/>
-                    <a:p>
-                      <a:pPr>
-                        <a:lnSpc>
-                          <a:spcPct val="100000"/>
-                        </a:lnSpc>
-                      </a:pPr>
-                      <a:r>
-                        <a:rPr sz="1050" b="0">
-                          <a:solidFill>
-                            <a:srgbClr val="1A1A1A"/>
-                          </a:solidFill>
-                          <a:latin typeface="Calibri"/>
-                        </a:rPr>
-                        <a:t>Panchromatic</a:t>
-                      </a:r>
-                    </a:p>
-                  </a:txBody>
-                  <a:tcPr anchor="ctr" marL="54864" marR="45720" marT="18288" marB="18288">
-                    <a:solidFill>
-                      <a:srgbClr val="F5F5F5"/>
-                    </a:solidFill>
-                  </a:tcPr>
-                </a:tc>
-                <a:tc>
-                  <a:txBody>
-                    <a:bodyPr/>
-                    <a:lstStyle/>
-                    <a:p>
-                      <a:pPr>
-                        <a:lnSpc>
-                          <a:spcPct val="100000"/>
-                        </a:lnSpc>
-                      </a:pPr>
-                      <a:r>
-                        <a:rPr sz="1050" b="0">
-                          <a:solidFill>
-                            <a:srgbClr val="1A1A1A"/>
-                          </a:solidFill>
-                          <a:latin typeface="Calibri"/>
-                        </a:rPr>
-                        <a:t>0.31 m</a:t>
-                      </a:r>
-                    </a:p>
-                  </a:txBody>
-                  <a:tcPr anchor="ctr" marL="54864" marR="45720" marT="18288" marB="18288">
-                    <a:solidFill>
-                      <a:srgbClr val="F5F5F5"/>
-                    </a:solidFill>
-                  </a:tcPr>
-                </a:tc>
-                <a:tc>
-                  <a:txBody>
-                    <a:bodyPr/>
-                    <a:lstStyle/>
-                    <a:p>
-                      <a:pPr>
-                        <a:lnSpc>
-                          <a:spcPct val="100000"/>
-                        </a:lnSpc>
-                      </a:pPr>
-                      <a:r>
-                        <a:rPr sz="1050" b="0">
-                          <a:solidFill>
-                            <a:srgbClr val="1A1A1A"/>
-                          </a:solidFill>
-                          <a:latin typeface="Calibri"/>
-                        </a:rPr>
-                        <a:t>0.30 m</a:t>
-                      </a:r>
-                    </a:p>
-                  </a:txBody>
-                  <a:tcPr anchor="ctr" marL="54864" marR="45720" marT="18288" marB="18288">
-                    <a:solidFill>
-                      <a:srgbClr val="F5F5F5"/>
-                    </a:solidFill>
-                  </a:tcPr>
-                </a:tc>
-              </a:tr>
-              <a:tr h="457200">
-                <a:tc>
-                  <a:txBody>
-                    <a:bodyPr/>
-                    <a:lstStyle/>
-                    <a:p>
-                      <a:pPr>
-                        <a:lnSpc>
-                          <a:spcPct val="100000"/>
-                        </a:lnSpc>
-                      </a:pPr>
-                      <a:r>
-                        <a:rPr sz="1050" b="0">
-                          <a:solidFill>
-                            <a:srgbClr val="1A1A1A"/>
-                          </a:solidFill>
-                          <a:latin typeface="Calibri"/>
-                        </a:rPr>
-                        <a:t>Extra bands vs RGB+NIR</a:t>
-                      </a:r>
-                    </a:p>
-                  </a:txBody>
-                  <a:tcPr anchor="ctr" marL="54864" marR="45720" marT="18288" marB="18288">
-                    <a:solidFill>
-                      <a:srgbClr val="FFFFFF"/>
-                    </a:solidFill>
-                  </a:tcPr>
-                </a:tc>
-                <a:tc>
-                  <a:txBody>
-                    <a:bodyPr/>
-                    <a:lstStyle/>
-                    <a:p>
-                      <a:pPr>
-                        <a:lnSpc>
-                          <a:spcPct val="100000"/>
-                        </a:lnSpc>
-                      </a:pPr>
-                      <a:r>
-                        <a:rPr sz="1050" b="0">
-                          <a:solidFill>
-                            <a:srgbClr val="1A1A1A"/>
-                          </a:solidFill>
-                          <a:latin typeface="Calibri"/>
-                        </a:rPr>
-                        <a:t>Coastal, Yellow, Red Edge, NIR2</a:t>
-                      </a:r>
-                    </a:p>
-                  </a:txBody>
-                  <a:tcPr anchor="ctr" marL="54864" marR="45720" marT="18288" marB="18288">
-                    <a:solidFill>
-                      <a:srgbClr val="FFFFFF"/>
-                    </a:solidFill>
-                  </a:tcPr>
-                </a:tc>
-                <a:tc>
-                  <a:txBody>
-                    <a:bodyPr/>
-                    <a:lstStyle/>
-                    <a:p>
-                      <a:pPr>
-                        <a:lnSpc>
-                          <a:spcPct val="100000"/>
-                        </a:lnSpc>
-                      </a:pPr>
-                      <a:r>
-                        <a:rPr sz="1050" b="0">
-                          <a:solidFill>
-                            <a:srgbClr val="1A1A1A"/>
-                          </a:solidFill>
-                          <a:latin typeface="Calibri"/>
-                        </a:rPr>
-                        <a:t>Deep Blue, Red Edge</a:t>
-                      </a:r>
-                    </a:p>
-                  </a:txBody>
-                  <a:tcPr anchor="ctr" marL="54864" marR="45720" marT="18288" marB="18288">
-                    <a:solidFill>
-                      <a:srgbClr val="FFFFFF"/>
-                    </a:solidFill>
-                  </a:tcPr>
-                </a:tc>
-              </a:tr>
-              <a:tr h="457200">
-                <a:tc>
-                  <a:txBody>
-                    <a:bodyPr/>
-                    <a:lstStyle/>
-                    <a:p>
-                      <a:pPr>
-                        <a:lnSpc>
-                          <a:spcPct val="100000"/>
-                        </a:lnSpc>
-                      </a:pPr>
-                      <a:r>
-                        <a:rPr sz="1050" b="0">
-                          <a:solidFill>
-                            <a:srgbClr val="1A1A1A"/>
-                          </a:solidFill>
-                          <a:latin typeface="Calibri"/>
-                        </a:rPr>
-                        <a:t>Access</a:t>
-                      </a:r>
-                    </a:p>
-                  </a:txBody>
-                  <a:tcPr anchor="ctr" marL="54864" marR="45720" marT="18288" marB="18288">
-                    <a:solidFill>
-                      <a:srgbClr val="F5F5F5"/>
-                    </a:solidFill>
-                  </a:tcPr>
-                </a:tc>
-                <a:tc>
-                  <a:txBody>
-                    <a:bodyPr/>
-                    <a:lstStyle/>
-                    <a:p>
-                      <a:pPr>
-                        <a:lnSpc>
-                          <a:spcPct val="100000"/>
-                        </a:lnSpc>
-                      </a:pPr>
-                      <a:r>
-                        <a:rPr sz="1050" b="0">
-                          <a:solidFill>
-                            <a:srgbClr val="1A1A1A"/>
-                          </a:solidFill>
-                          <a:latin typeface="Calibri"/>
-                        </a:rPr>
-                        <a:t>commercial / ESA proposal</a:t>
-                      </a:r>
-                    </a:p>
-                  </a:txBody>
-                  <a:tcPr anchor="ctr" marL="54864" marR="45720" marT="18288" marB="18288">
-                    <a:solidFill>
-                      <a:srgbClr val="F5F5F5"/>
-                    </a:solidFill>
-                  </a:tcPr>
-                </a:tc>
-                <a:tc>
-                  <a:txBody>
-                    <a:bodyPr/>
-                    <a:lstStyle/>
-                    <a:p>
-                      <a:pPr>
-                        <a:lnSpc>
-                          <a:spcPct val="100000"/>
-                        </a:lnSpc>
-                      </a:pPr>
-                      <a:r>
-                        <a:rPr sz="1050" b="0">
-                          <a:solidFill>
-                            <a:srgbClr val="1A1A1A"/>
-                          </a:solidFill>
-                          <a:latin typeface="Calibri"/>
-                        </a:rPr>
-                        <a:t>commercial / ESA proposal</a:t>
-                      </a:r>
-                    </a:p>
-                  </a:txBody>
-                  <a:tcPr anchor="ctr" marL="54864" marR="45720" marT="18288" marB="18288">
-                    <a:solidFill>
-                      <a:srgbClr val="F5F5F5"/>
-                    </a:solidFill>
-                  </a:tcPr>
-                </a:tc>
-              </a:tr>
-            </a:tbl>
-          </a:graphicData>
-        </a:graphic>
-      </p:graphicFrame>
+        </p:nvPicPr>
+        <p:blipFill>
+          <a:blip r:embed="rId2"/>
+          <a:stretch>
+            <a:fillRect/>
+          </a:stretch>
+        </p:blipFill>
+        <p:spPr>
+          <a:xfrm>
+            <a:off x="1249951" y="960120"/>
+            <a:ext cx="6644097" cy="2606040"/>
+          </a:xfrm>
+          <a:prstGeom prst="rect">
+            <a:avLst/>
+          </a:prstGeom>
+        </p:spPr>
+      </p:pic>
       <p:sp>
         <p:nvSpPr>
           <p:cNvPr id="4" name="TextBox 3"/>
@@ -9064,8 +8086,8 @@
         </p:nvSpPr>
         <p:spPr>
           <a:xfrm>
-            <a:off x="411480" y="3794760"/>
-            <a:ext cx="8321040" cy="685800"/>
+            <a:off x="411480" y="3703320"/>
+            <a:ext cx="8321040" cy="960120"/>
           </a:xfrm>
           <a:prstGeom prst="rect">
             <a:avLst/>
@@ -9080,7 +8102,7 @@
           <a:p>
             <a:pPr algn="l">
               <a:lnSpc>
-                <a:spcPct val="115000"/>
+                <a:spcPct val="112000"/>
               </a:lnSpc>
               <a:spcAft>
                 <a:spcPts val="600"/>
@@ -9093,7 +8115,26 @@
                 </a:solidFill>
                 <a:latin typeface="Calibri"/>
               </a:rPr>
-              <a:t>Both sensors are sub-metre with pan-sharpening and carry VNIR beyond RGB. This is the band budget of the study: no SWIR, no Sentinel-2.</a:t>
+              <a:t>Panchromatic: 0.31 m (WorldView-3), 0.30 m (Pléiades Neo). Access: commercial, or free quota via ESA proposal.</a:t>
+            </a:r>
+          </a:p>
+          <a:p>
+            <a:pPr algn="l">
+              <a:lnSpc>
+                <a:spcPct val="112000"/>
+              </a:lnSpc>
+              <a:spcAft>
+                <a:spcPts val="600"/>
+              </a:spcAft>
+            </a:pPr>
+            <a:r>
+              <a:rPr sz="1200" b="0" i="0">
+                <a:solidFill>
+                  <a:srgbClr val="1A1A1A"/>
+                </a:solidFill>
+                <a:latin typeface="Calibri"/>
+              </a:rPr>
+              <a:t>This is the band budget of the study: no SWIR, no Sentinel-2. RGB baseline runs on AerialWaste (20-50 cm).</a:t>
             </a:r>
           </a:p>
         </p:txBody>
@@ -9106,7 +8147,7 @@
         </p:nvSpPr>
         <p:spPr>
           <a:xfrm>
-            <a:off x="411480" y="4791456"/>
+            <a:off x="411480" y="4809744"/>
             <a:ext cx="8321040" cy="237744"/>
           </a:xfrm>
           <a:prstGeom prst="rect">
@@ -9122,7 +8163,7 @@
           <a:p>
             <a:pPr algn="l">
               <a:lnSpc>
-                <a:spcPct val="115000"/>
+                <a:spcPct val="112000"/>
               </a:lnSpc>
               <a:spcAft>
                 <a:spcPts val="0"/>
@@ -9135,7 +8176,7 @@
                 </a:solidFill>
                 <a:latin typeface="Calibri"/>
               </a:rPr>
-              <a:t>Specs: Maxar WorldView-3, Airbus Pléiades Neo. Reference RGB baseline data: AerialWaste (20-50 cm).</a:t>
+              <a:t>Band ranges: Maxar WorldView-3, Airbus Pléiades Neo data sheets</a:t>
             </a:r>
           </a:p>
         </p:txBody>
@@ -9148,7 +8189,7 @@
         </p:nvSpPr>
         <p:spPr>
           <a:xfrm>
-            <a:off x="91440" y="4791456"/>
+            <a:off x="91440" y="4809744"/>
             <a:ext cx="411480" cy="256032"/>
           </a:xfrm>
           <a:prstGeom prst="rect">

</xml_diff>